<commit_message>
Paper: insert all paper/figures into talk deck (13 slides, 9 figures)
Added two_image_slide helper; new slides place the previously-unused figures:
- SP#2 remanence (FigS3 + FigS3b) after µMAG validation
- cross-solver throughput (Fig3a + Fig3b) after the performance landscape
All 9 figures in paper/figures/ now appear on their related pages.

Co-Authored-By: Claude Opus 4.8 <noreply@anthropic.com>
</commit_message>
<xml_diff>
--- a/paper/Claude-SD_talk.pptx
+++ b/paper/Claude-SD_talk.pptx
@@ -16,6 +16,8 @@
     <p:sldId id="264" r:id="rId15"/>
     <p:sldId id="265" r:id="rId16"/>
     <p:sldId id="266" r:id="rId17"/>
+    <p:sldId id="267" r:id="rId18"/>
+    <p:sldId id="268" r:id="rId19"/>
   </p:sldIdLst>
   <p:sldSz cx="12191695" cy="6858000" type="screen4x3"/>
   <p:notesSz cx="6858000" cy="9144000"/>
@@ -3337,7 +3339,7 @@
               </a:defRPr>
             </a:pPr>
             <a:r>
-              <a:t>Why it matters</a:t>
+              <a:t>The key result: a hidden defect</a:t>
             </a:r>
           </a:p>
         </p:txBody>
@@ -3375,7 +3377,22 @@
               </a:defRPr>
             </a:pPr>
             <a:r>
-              <a:t>• The agent did NOT write defect-free code — it wrote a subtle GPU race</a:t>
+              <a:t>• Relax a seeded skyrmion across the DMI boundary; record topological charge Q</a:t>
+            </a:r>
+          </a:p>
+          <a:p>
+            <a:pPr>
+              <a:spcAft>
+                <a:spcPts val="700"/>
+              </a:spcAft>
+              <a:defRPr sz="2200" b="1">
+                <a:solidFill>
+                  <a:srgbClr val="C02A2A"/>
+                </a:solidFill>
+              </a:defRPr>
+            </a:pPr>
+            <a:r>
+              <a:t>• Same Claude-SD build, repeated identical runs  →  DIFFERENT Q</a:t>
             </a:r>
           </a:p>
           <a:p>
@@ -3385,12 +3402,27 @@
               </a:spcAft>
               <a:defRPr sz="1900" b="0">
                 <a:solidFill>
+                  <a:srgbClr val="C02A2A"/>
+                </a:solidFill>
+              </a:defRPr>
+            </a:pPr>
+            <a:r>
+              <a:t>   – run-to-run std of Q up to 0.48  — even in DOUBLE precision</a:t>
+            </a:r>
+          </a:p>
+          <a:p>
+            <a:pPr lvl="1">
+              <a:spcAft>
+                <a:spcPts val="700"/>
+              </a:spcAft>
+              <a:defRPr sz="1900" b="0">
+                <a:solidFill>
                   <a:srgbClr val="444444"/>
                 </a:solidFill>
               </a:defRPr>
             </a:pPr>
             <a:r>
-              <a:t>   – …that passed every unit test and every standard problem</a:t>
+              <a:t>   – Q scattered across topological sectors [−1.5, +1.5]</a:t>
             </a:r>
           </a:p>
           <a:p>
@@ -3405,7 +3437,7 @@
               </a:defRPr>
             </a:pPr>
             <a:r>
-              <a:t>• What caught it: deliberately redundant design</a:t>
+              <a:t>• mumax3 (relax &amp; minimize): deterministic, robust  →  the diagnostic signal</a:t>
             </a:r>
           </a:p>
           <a:p>
@@ -3420,67 +3452,42 @@
               </a:defRPr>
             </a:pPr>
             <a:r>
-              <a:t>   – multiple precisions × FFT backends × independent solvers</a:t>
-            </a:r>
-          </a:p>
-          <a:p>
-            <a:pPr lvl="1">
-              <a:spcAft>
-                <a:spcPts val="700"/>
-              </a:spcAft>
-              <a:defRPr sz="1900" b="0">
+              <a:t>   – A correct relaxation must not depend on thread scheduling  →  a defect</a:t>
+            </a:r>
+          </a:p>
+        </p:txBody>
+      </p:sp>
+      <p:sp>
+        <p:nvSpPr>
+          <p:cNvPr id="5" name="TextBox 4"/>
+          <p:cNvSpPr txBox="1"/>
+          <p:nvPr/>
+        </p:nvSpPr>
+        <p:spPr>
+          <a:xfrm>
+            <a:off x="640080" y="6263640"/>
+            <a:ext cx="10972800" cy="457200"/>
+          </a:xfrm>
+          <a:prstGeom prst="rect">
+            <a:avLst/>
+          </a:prstGeom>
+          <a:noFill/>
+        </p:spPr>
+        <p:txBody>
+          <a:bodyPr wrap="square">
+            <a:spAutoFit/>
+          </a:bodyPr>
+          <a:lstStyle/>
+          <a:p>
+            <a:pPr>
+              <a:defRPr sz="1200" i="1">
                 <a:solidFill>
                   <a:srgbClr val="444444"/>
                 </a:solidFill>
               </a:defRPr>
             </a:pPr>
             <a:r>
-              <a:t>   – Discrepancy (CS scatter vs mumax3 determinism) was the diagnostic</a:t>
-            </a:r>
-          </a:p>
-          <a:p>
-            <a:pPr>
-              <a:spcAft>
-                <a:spcPts val="700"/>
-              </a:spcAft>
-              <a:defRPr sz="2200" b="1">
-                <a:solidFill>
-                  <a:srgbClr val="C02A2A"/>
-                </a:solidFill>
-              </a:defRPr>
-            </a:pPr>
-            <a:r>
-              <a:t>• Takeaway</a:t>
-            </a:r>
-          </a:p>
-          <a:p>
-            <a:pPr lvl="1">
-              <a:spcAft>
-                <a:spcPts val="700"/>
-              </a:spcAft>
-              <a:defRPr sz="1900" b="0">
-                <a:solidFill>
-                  <a:srgbClr val="444444"/>
-                </a:solidFill>
-              </a:defRPr>
-            </a:pPr>
-            <a:r>
-              <a:t>   – for AI-built scientific software, cross-implementation validation must be a</a:t>
-            </a:r>
-          </a:p>
-          <a:p>
-            <a:pPr lvl="1">
-              <a:spcAft>
-                <a:spcPts val="700"/>
-              </a:spcAft>
-              <a:defRPr sz="1900" b="0">
-                <a:solidFill>
-                  <a:srgbClr val="444444"/>
-                </a:solidFill>
-              </a:defRPr>
-            </a:pPr>
-            <a:r>
-              <a:t>   – first-class design goal — the failure mode is plausible code that is subtly wrong</a:t>
+              <a:t>Fig. 4a</a:t>
             </a:r>
           </a:p>
         </p:txBody>
@@ -3576,6 +3583,478 @@
               </a:defRPr>
             </a:pPr>
             <a:r>
+              <a:t>Diagnosis → fix → determinism restored</a:t>
+            </a:r>
+          </a:p>
+        </p:txBody>
+      </p:sp>
+      <p:pic>
+        <p:nvPicPr>
+          <p:cNvPr id="4" name="Picture 3" descr="Fig4_race_fix.png"/>
+          <p:cNvPicPr>
+            <a:picLocks noChangeAspect="1"/>
+          </p:cNvPicPr>
+          <p:nvPr/>
+        </p:nvPicPr>
+        <p:blipFill>
+          <a:blip r:embed="rId2"/>
+          <a:stretch>
+            <a:fillRect/>
+          </a:stretch>
+        </p:blipFill>
+        <p:spPr>
+          <a:xfrm>
+            <a:off x="320040" y="1143000"/>
+            <a:ext cx="7315017" cy="2350503"/>
+          </a:xfrm>
+          <a:prstGeom prst="rect">
+            <a:avLst/>
+          </a:prstGeom>
+        </p:spPr>
+      </p:pic>
+      <p:sp>
+        <p:nvSpPr>
+          <p:cNvPr id="5" name="TextBox 4"/>
+          <p:cNvSpPr txBox="1"/>
+          <p:nvPr/>
+        </p:nvSpPr>
+        <p:spPr>
+          <a:xfrm>
+            <a:off x="7863657" y="1280160"/>
+            <a:ext cx="4053718" cy="4937760"/>
+          </a:xfrm>
+          <a:prstGeom prst="rect">
+            <a:avLst/>
+          </a:prstGeom>
+          <a:noFill/>
+        </p:spPr>
+        <p:txBody>
+          <a:bodyPr wrap="square">
+            <a:spAutoFit/>
+          </a:bodyPr>
+          <a:lstStyle/>
+          <a:p>
+            <a:pPr>
+              <a:spcAft>
+                <a:spcPts val="800"/>
+              </a:spcAft>
+              <a:defRPr sz="1600">
+                <a:solidFill>
+                  <a:srgbClr val="444444"/>
+                </a:solidFill>
+              </a:defRPr>
+            </a:pPr>
+            <a:r>
+              <a:t>• Bisection: only damped-LLG + DMI scattered</a:t>
+            </a:r>
+          </a:p>
+          <a:p>
+            <a:pPr>
+              <a:spcAft>
+                <a:spcPts val="800"/>
+              </a:spcAft>
+              <a:defRPr sz="1600">
+                <a:solidFill>
+                  <a:srgbClr val="444444"/>
+                </a:solidFill>
+              </a:defRPr>
+            </a:pPr>
+            <a:r>
+              <a:t>• Cause: DMI GPU field missing set_stream override</a:t>
+            </a:r>
+          </a:p>
+          <a:p>
+            <a:pPr>
+              <a:spcAft>
+                <a:spcPts val="800"/>
+              </a:spcAft>
+              <a:defRPr sz="1600">
+                <a:solidFill>
+                  <a:srgbClr val="444444"/>
+                </a:solidFill>
+              </a:defRPr>
+            </a:pPr>
+            <a:r>
+              <a:t>• -&gt; ran on its own stream, racing on d_H_out</a:t>
+            </a:r>
+          </a:p>
+          <a:p>
+            <a:pPr>
+              <a:spcAft>
+                <a:spcPts val="800"/>
+              </a:spcAft>
+              <a:defRPr sz="1600">
+                <a:solidFill>
+                  <a:srgbClr val="444444"/>
+                </a:solidFill>
+              </a:defRPr>
+            </a:pPr>
+            <a:r>
+              <a:t>• (FieldSumGPU single-stream mode skips sync)</a:t>
+            </a:r>
+          </a:p>
+          <a:p>
+            <a:pPr>
+              <a:spcAft>
+                <a:spcPts val="800"/>
+              </a:spcAft>
+              <a:defRPr sz="1600">
+                <a:solidFill>
+                  <a:srgbClr val="444444"/>
+                </a:solidFill>
+              </a:defRPr>
+            </a:pPr>
+            <a:r>
+              <a:t>• Fix: add override -&gt; std(Q) = 0, all builds</a:t>
+            </a:r>
+          </a:p>
+          <a:p>
+            <a:pPr>
+              <a:spcAft>
+                <a:spcPts val="800"/>
+              </a:spcAft>
+              <a:defRPr sz="1600">
+                <a:solidFill>
+                  <a:srgbClr val="444444"/>
+                </a:solidFill>
+              </a:defRPr>
+            </a:pPr>
+            <a:r>
+              <a:t>• Invisible to single build &amp; standard problems</a:t>
+            </a:r>
+          </a:p>
+        </p:txBody>
+      </p:sp>
+    </p:spTree>
+  </p:cSld>
+  <p:clrMapOvr>
+    <a:masterClrMapping/>
+  </p:clrMapOvr>
+</p:sld>
+</file>
+
+<file path=ppt/slides/slide12.xml><?xml version="1.0" encoding="utf-8"?>
+<p:sld xmlns:a="http://schemas.openxmlformats.org/drawingml/2006/main" xmlns:p="http://schemas.openxmlformats.org/presentationml/2006/main" xmlns:r="http://schemas.openxmlformats.org/officeDocument/2006/relationships">
+  <p:cSld>
+    <p:spTree>
+      <p:nvGrpSpPr>
+        <p:cNvPr id="1" name=""/>
+        <p:cNvGrpSpPr/>
+        <p:nvPr/>
+      </p:nvGrpSpPr>
+      <p:grpSpPr/>
+      <p:sp>
+        <p:nvSpPr>
+          <p:cNvPr id="2" name="Rectangle 1"/>
+          <p:cNvSpPr/>
+          <p:nvPr/>
+        </p:nvSpPr>
+        <p:spPr>
+          <a:xfrm>
+            <a:off x="0" y="0"/>
+            <a:ext cx="12191695" cy="109728"/>
+          </a:xfrm>
+          <a:prstGeom prst="rect">
+            <a:avLst/>
+          </a:prstGeom>
+          <a:solidFill>
+            <a:srgbClr val="1F3A5F"/>
+          </a:solidFill>
+          <a:ln>
+            <a:noFill/>
+          </a:ln>
+        </p:spPr>
+        <p:style>
+          <a:lnRef idx="1">
+            <a:schemeClr val="accent1"/>
+          </a:lnRef>
+          <a:fillRef idx="3">
+            <a:schemeClr val="accent1"/>
+          </a:fillRef>
+          <a:effectRef idx="2">
+            <a:schemeClr val="accent1"/>
+          </a:effectRef>
+          <a:fontRef idx="minor">
+            <a:schemeClr val="lt1"/>
+          </a:fontRef>
+        </p:style>
+        <p:txBody>
+          <a:bodyPr rtlCol="0" anchor="ctr"/>
+          <a:lstStyle/>
+          <a:p>
+            <a:pPr algn="ctr"/>
+          </a:p>
+        </p:txBody>
+      </p:sp>
+      <p:sp>
+        <p:nvSpPr>
+          <p:cNvPr id="3" name="TextBox 2"/>
+          <p:cNvSpPr txBox="1"/>
+          <p:nvPr/>
+        </p:nvSpPr>
+        <p:spPr>
+          <a:xfrm>
+            <a:off x="457200" y="201168"/>
+            <a:ext cx="11247120" cy="731520"/>
+          </a:xfrm>
+          <a:prstGeom prst="rect">
+            <a:avLst/>
+          </a:prstGeom>
+          <a:noFill/>
+        </p:spPr>
+        <p:txBody>
+          <a:bodyPr wrap="square">
+            <a:spAutoFit/>
+          </a:bodyPr>
+          <a:lstStyle/>
+          <a:p>
+            <a:pPr>
+              <a:defRPr sz="2600" b="1">
+                <a:solidFill>
+                  <a:srgbClr val="1F3A5F"/>
+                </a:solidFill>
+              </a:defRPr>
+            </a:pPr>
+            <a:r>
+              <a:t>Why it matters</a:t>
+            </a:r>
+          </a:p>
+        </p:txBody>
+      </p:sp>
+      <p:sp>
+        <p:nvSpPr>
+          <p:cNvPr id="4" name="TextBox 3"/>
+          <p:cNvSpPr txBox="1"/>
+          <p:nvPr/>
+        </p:nvSpPr>
+        <p:spPr>
+          <a:xfrm>
+            <a:off x="640080" y="1143000"/>
+            <a:ext cx="10972800" cy="4846320"/>
+          </a:xfrm>
+          <a:prstGeom prst="rect">
+            <a:avLst/>
+          </a:prstGeom>
+          <a:noFill/>
+        </p:spPr>
+        <p:txBody>
+          <a:bodyPr wrap="square">
+            <a:spAutoFit/>
+          </a:bodyPr>
+          <a:lstStyle/>
+          <a:p>
+            <a:pPr>
+              <a:spcAft>
+                <a:spcPts val="700"/>
+              </a:spcAft>
+              <a:defRPr sz="2200" b="0">
+                <a:solidFill>
+                  <a:srgbClr val="1F3A5F"/>
+                </a:solidFill>
+              </a:defRPr>
+            </a:pPr>
+            <a:r>
+              <a:t>• The agent did NOT write defect-free code — it wrote a subtle GPU race</a:t>
+            </a:r>
+          </a:p>
+          <a:p>
+            <a:pPr lvl="1">
+              <a:spcAft>
+                <a:spcPts val="700"/>
+              </a:spcAft>
+              <a:defRPr sz="1900" b="0">
+                <a:solidFill>
+                  <a:srgbClr val="444444"/>
+                </a:solidFill>
+              </a:defRPr>
+            </a:pPr>
+            <a:r>
+              <a:t>   – …that passed every unit test and every standard problem</a:t>
+            </a:r>
+          </a:p>
+          <a:p>
+            <a:pPr>
+              <a:spcAft>
+                <a:spcPts val="700"/>
+              </a:spcAft>
+              <a:defRPr sz="2200" b="0">
+                <a:solidFill>
+                  <a:srgbClr val="1F77B4"/>
+                </a:solidFill>
+              </a:defRPr>
+            </a:pPr>
+            <a:r>
+              <a:t>• What caught it: deliberately redundant design</a:t>
+            </a:r>
+          </a:p>
+          <a:p>
+            <a:pPr lvl="1">
+              <a:spcAft>
+                <a:spcPts val="700"/>
+              </a:spcAft>
+              <a:defRPr sz="1900" b="0">
+                <a:solidFill>
+                  <a:srgbClr val="444444"/>
+                </a:solidFill>
+              </a:defRPr>
+            </a:pPr>
+            <a:r>
+              <a:t>   – multiple precisions × FFT backends × independent solvers</a:t>
+            </a:r>
+          </a:p>
+          <a:p>
+            <a:pPr lvl="1">
+              <a:spcAft>
+                <a:spcPts val="700"/>
+              </a:spcAft>
+              <a:defRPr sz="1900" b="0">
+                <a:solidFill>
+                  <a:srgbClr val="444444"/>
+                </a:solidFill>
+              </a:defRPr>
+            </a:pPr>
+            <a:r>
+              <a:t>   – Discrepancy (CS scatter vs mumax3 determinism) was the diagnostic</a:t>
+            </a:r>
+          </a:p>
+          <a:p>
+            <a:pPr>
+              <a:spcAft>
+                <a:spcPts val="700"/>
+              </a:spcAft>
+              <a:defRPr sz="2200" b="1">
+                <a:solidFill>
+                  <a:srgbClr val="C02A2A"/>
+                </a:solidFill>
+              </a:defRPr>
+            </a:pPr>
+            <a:r>
+              <a:t>• Takeaway</a:t>
+            </a:r>
+          </a:p>
+          <a:p>
+            <a:pPr lvl="1">
+              <a:spcAft>
+                <a:spcPts val="700"/>
+              </a:spcAft>
+              <a:defRPr sz="1900" b="0">
+                <a:solidFill>
+                  <a:srgbClr val="444444"/>
+                </a:solidFill>
+              </a:defRPr>
+            </a:pPr>
+            <a:r>
+              <a:t>   – for AI-built scientific software, cross-implementation validation must be a</a:t>
+            </a:r>
+          </a:p>
+          <a:p>
+            <a:pPr lvl="1">
+              <a:spcAft>
+                <a:spcPts val="700"/>
+              </a:spcAft>
+              <a:defRPr sz="1900" b="0">
+                <a:solidFill>
+                  <a:srgbClr val="444444"/>
+                </a:solidFill>
+              </a:defRPr>
+            </a:pPr>
+            <a:r>
+              <a:t>   – first-class design goal — the failure mode is plausible code that is subtly wrong</a:t>
+            </a:r>
+          </a:p>
+        </p:txBody>
+      </p:sp>
+    </p:spTree>
+  </p:cSld>
+  <p:clrMapOvr>
+    <a:masterClrMapping/>
+  </p:clrMapOvr>
+</p:sld>
+</file>
+
+<file path=ppt/slides/slide13.xml><?xml version="1.0" encoding="utf-8"?>
+<p:sld xmlns:a="http://schemas.openxmlformats.org/drawingml/2006/main" xmlns:p="http://schemas.openxmlformats.org/presentationml/2006/main" xmlns:r="http://schemas.openxmlformats.org/officeDocument/2006/relationships">
+  <p:cSld>
+    <p:spTree>
+      <p:nvGrpSpPr>
+        <p:cNvPr id="1" name=""/>
+        <p:cNvGrpSpPr/>
+        <p:nvPr/>
+      </p:nvGrpSpPr>
+      <p:grpSpPr/>
+      <p:sp>
+        <p:nvSpPr>
+          <p:cNvPr id="2" name="Rectangle 1"/>
+          <p:cNvSpPr/>
+          <p:nvPr/>
+        </p:nvSpPr>
+        <p:spPr>
+          <a:xfrm>
+            <a:off x="0" y="0"/>
+            <a:ext cx="12191695" cy="109728"/>
+          </a:xfrm>
+          <a:prstGeom prst="rect">
+            <a:avLst/>
+          </a:prstGeom>
+          <a:solidFill>
+            <a:srgbClr val="1F3A5F"/>
+          </a:solidFill>
+          <a:ln>
+            <a:noFill/>
+          </a:ln>
+        </p:spPr>
+        <p:style>
+          <a:lnRef idx="1">
+            <a:schemeClr val="accent1"/>
+          </a:lnRef>
+          <a:fillRef idx="3">
+            <a:schemeClr val="accent1"/>
+          </a:fillRef>
+          <a:effectRef idx="2">
+            <a:schemeClr val="accent1"/>
+          </a:effectRef>
+          <a:fontRef idx="minor">
+            <a:schemeClr val="lt1"/>
+          </a:fontRef>
+        </p:style>
+        <p:txBody>
+          <a:bodyPr rtlCol="0" anchor="ctr"/>
+          <a:lstStyle/>
+          <a:p>
+            <a:pPr algn="ctr"/>
+          </a:p>
+        </p:txBody>
+      </p:sp>
+      <p:sp>
+        <p:nvSpPr>
+          <p:cNvPr id="3" name="TextBox 2"/>
+          <p:cNvSpPr txBox="1"/>
+          <p:nvPr/>
+        </p:nvSpPr>
+        <p:spPr>
+          <a:xfrm>
+            <a:off x="457200" y="201168"/>
+            <a:ext cx="11247120" cy="731520"/>
+          </a:xfrm>
+          <a:prstGeom prst="rect">
+            <a:avLst/>
+          </a:prstGeom>
+          <a:noFill/>
+        </p:spPr>
+        <p:txBody>
+          <a:bodyPr wrap="square">
+            <a:spAutoFit/>
+          </a:bodyPr>
+          <a:lstStyle/>
+          <a:p>
+            <a:pPr>
+              <a:defRPr sz="2600" b="1">
+                <a:solidFill>
+                  <a:srgbClr val="1F3A5F"/>
+                </a:solidFill>
+              </a:defRPr>
+            </a:pPr>
+            <a:r>
               <a:t>Summary</a:t>
             </a:r>
           </a:p>
@@ -4827,14 +5306,14 @@
               </a:defRPr>
             </a:pPr>
             <a:r>
-              <a:t>Performance: a precision/size trade-off</a:t>
+              <a:t>SP#2 remanence — cross-solver agreement</a:t>
             </a:r>
           </a:p>
         </p:txBody>
       </p:sp>
       <p:pic>
         <p:nvPicPr>
-          <p:cNvPr id="4" name="Picture 3" descr="Fig5_landscape.png"/>
+          <p:cNvPr id="4" name="Picture 3" descr="FigS3_sp2.png"/>
           <p:cNvPicPr>
             <a:picLocks noChangeAspect="1"/>
           </p:cNvPicPr>
@@ -4848,24 +5327,48 @@
         </p:blipFill>
         <p:spPr>
           <a:xfrm>
-            <a:off x="320040" y="1143000"/>
-            <a:ext cx="7315017" cy="2802703"/>
+            <a:off x="274320" y="1280160"/>
+            <a:ext cx="5547207" cy="2168454"/>
           </a:xfrm>
           <a:prstGeom prst="rect">
             <a:avLst/>
           </a:prstGeom>
         </p:spPr>
       </p:pic>
-      <p:sp>
-        <p:nvSpPr>
-          <p:cNvPr id="5" name="TextBox 4"/>
+      <p:pic>
+        <p:nvPicPr>
+          <p:cNvPr id="5" name="Picture 4" descr="FigS3b_sp2_crosssolver.png"/>
+          <p:cNvPicPr>
+            <a:picLocks noChangeAspect="1"/>
+          </p:cNvPicPr>
+          <p:nvPr/>
+        </p:nvPicPr>
+        <p:blipFill>
+          <a:blip r:embed="rId3"/>
+          <a:stretch>
+            <a:fillRect/>
+          </a:stretch>
+        </p:blipFill>
+        <p:spPr>
+          <a:xfrm>
+            <a:off x="6370167" y="1280160"/>
+            <a:ext cx="5547207" cy="3669691"/>
+          </a:xfrm>
+          <a:prstGeom prst="rect">
+            <a:avLst/>
+          </a:prstGeom>
+        </p:spPr>
+      </p:pic>
+      <p:sp>
+        <p:nvSpPr>
+          <p:cNvPr id="6" name="TextBox 5"/>
           <p:cNvSpPr txBox="1"/>
           <p:nvPr/>
         </p:nvSpPr>
         <p:spPr>
           <a:xfrm>
-            <a:off x="7863657" y="1280160"/>
-            <a:ext cx="4053718" cy="4937760"/>
+            <a:off x="640080" y="6126480"/>
+            <a:ext cx="10972800" cy="548640"/>
           </a:xfrm>
           <a:prstGeom prst="rect">
             <a:avLst/>
@@ -4878,78 +5381,15 @@
           </a:bodyPr>
           <a:lstStyle/>
           <a:p>
-            <a:pPr>
-              <a:spcAft>
-                <a:spcPts val="800"/>
-              </a:spcAft>
-              <a:defRPr sz="1600">
+            <a:pPr algn="ctr">
+              <a:defRPr sz="1500">
                 <a:solidFill>
                   <a:srgbClr val="444444"/>
                 </a:solidFill>
               </a:defRPr>
             </a:pPr>
             <a:r>
-              <a:t>• Crossover ~0.1–0.5 M cells</a:t>
-            </a:r>
-          </a:p>
-          <a:p>
-            <a:pPr>
-              <a:spcAft>
-                <a:spcPts val="800"/>
-              </a:spcAft>
-              <a:defRPr sz="1600">
-                <a:solidFill>
-                  <a:srgbClr val="444444"/>
-                </a:solidFill>
-              </a:defRPr>
-            </a:pPr>
-            <a:r>
-              <a:t>• Small / 2-D: CS f32 fastest (5.3× vs mumax3) — CUDA-Graph</a:t>
-            </a:r>
-          </a:p>
-          <a:p>
-            <a:pPr>
-              <a:spcAft>
-                <a:spcPts val="800"/>
-              </a:spcAft>
-              <a:defRPr sz="1600">
-                <a:solidFill>
-                  <a:srgbClr val="444444"/>
-                </a:solidFill>
-              </a:defRPr>
-            </a:pPr>
-            <a:r>
-              <a:t>• Large 3-D: mumax3 / MuMax-CO lead (cuFFT-bound)</a:t>
-            </a:r>
-          </a:p>
-          <a:p>
-            <a:pPr>
-              <a:spcAft>
-                <a:spcPts val="800"/>
-              </a:spcAft>
-              <a:defRPr sz="1600">
-                <a:solidFill>
-                  <a:srgbClr val="444444"/>
-                </a:solidFill>
-              </a:defRPr>
-            </a:pPr>
-            <a:r>
-              <a:t>• f32 = 4–6× f64 (Blackwell Tensor-Core)</a:t>
-            </a:r>
-          </a:p>
-          <a:p>
-            <a:pPr>
-              <a:spcAft>
-                <a:spcPts val="800"/>
-              </a:spcAft>
-              <a:defRPr sz="1600">
-                <a:solidFill>
-                  <a:srgbClr val="444444"/>
-                </a:solidFill>
-              </a:defRPr>
-            </a:pPr>
-            <a:r>
-              <a:t>• No single code wins everywhere</a:t>
+              <a:t>Remanent ⟨m⟩/M_s and coercivity vs d/ℓ_ex; Claude-SD vs mumax3 (≤0.006).</a:t>
             </a:r>
           </a:p>
         </p:txBody>
@@ -5045,21 +5485,45 @@
               </a:defRPr>
             </a:pPr>
             <a:r>
-              <a:t>The key result: a hidden defect</a:t>
-            </a:r>
-          </a:p>
-        </p:txBody>
-      </p:sp>
-      <p:sp>
-        <p:nvSpPr>
-          <p:cNvPr id="4" name="TextBox 3"/>
+              <a:t>Performance: a precision/size trade-off</a:t>
+            </a:r>
+          </a:p>
+        </p:txBody>
+      </p:sp>
+      <p:pic>
+        <p:nvPicPr>
+          <p:cNvPr id="4" name="Picture 3" descr="Fig5_landscape.png"/>
+          <p:cNvPicPr>
+            <a:picLocks noChangeAspect="1"/>
+          </p:cNvPicPr>
+          <p:nvPr/>
+        </p:nvPicPr>
+        <p:blipFill>
+          <a:blip r:embed="rId2"/>
+          <a:stretch>
+            <a:fillRect/>
+          </a:stretch>
+        </p:blipFill>
+        <p:spPr>
+          <a:xfrm>
+            <a:off x="320040" y="1143000"/>
+            <a:ext cx="7315017" cy="2802703"/>
+          </a:xfrm>
+          <a:prstGeom prst="rect">
+            <a:avLst/>
+          </a:prstGeom>
+        </p:spPr>
+      </p:pic>
+      <p:sp>
+        <p:nvSpPr>
+          <p:cNvPr id="5" name="TextBox 4"/>
           <p:cNvSpPr txBox="1"/>
           <p:nvPr/>
         </p:nvSpPr>
         <p:spPr>
           <a:xfrm>
-            <a:off x="640080" y="1143000"/>
-            <a:ext cx="10972800" cy="4846320"/>
+            <a:off x="7863657" y="1280160"/>
+            <a:ext cx="4053718" cy="4937760"/>
           </a:xfrm>
           <a:prstGeom prst="rect">
             <a:avLst/>
@@ -5074,126 +5538,76 @@
           <a:p>
             <a:pPr>
               <a:spcAft>
-                <a:spcPts val="700"/>
+                <a:spcPts val="800"/>
               </a:spcAft>
-              <a:defRPr sz="2200" b="0">
-                <a:solidFill>
-                  <a:srgbClr val="1F3A5F"/>
-                </a:solidFill>
-              </a:defRPr>
-            </a:pPr>
-            <a:r>
-              <a:t>• Relax a seeded skyrmion across the DMI boundary; record topological charge Q</a:t>
+              <a:defRPr sz="1600">
+                <a:solidFill>
+                  <a:srgbClr val="444444"/>
+                </a:solidFill>
+              </a:defRPr>
+            </a:pPr>
+            <a:r>
+              <a:t>• Crossover ~0.1–0.5 M cells</a:t>
             </a:r>
           </a:p>
           <a:p>
             <a:pPr>
               <a:spcAft>
-                <a:spcPts val="700"/>
+                <a:spcPts val="800"/>
               </a:spcAft>
-              <a:defRPr sz="2200" b="1">
-                <a:solidFill>
-                  <a:srgbClr val="C02A2A"/>
-                </a:solidFill>
-              </a:defRPr>
-            </a:pPr>
-            <a:r>
-              <a:t>• Same Claude-SD build, repeated identical runs  →  DIFFERENT Q</a:t>
-            </a:r>
-          </a:p>
-          <a:p>
-            <a:pPr lvl="1">
-              <a:spcAft>
-                <a:spcPts val="700"/>
-              </a:spcAft>
-              <a:defRPr sz="1900" b="0">
-                <a:solidFill>
-                  <a:srgbClr val="C02A2A"/>
-                </a:solidFill>
-              </a:defRPr>
-            </a:pPr>
-            <a:r>
-              <a:t>   – run-to-run std of Q up to 0.48  — even in DOUBLE precision</a:t>
-            </a:r>
-          </a:p>
-          <a:p>
-            <a:pPr lvl="1">
-              <a:spcAft>
-                <a:spcPts val="700"/>
-              </a:spcAft>
-              <a:defRPr sz="1900" b="0">
+              <a:defRPr sz="1600">
                 <a:solidFill>
                   <a:srgbClr val="444444"/>
                 </a:solidFill>
               </a:defRPr>
             </a:pPr>
             <a:r>
-              <a:t>   – Q scattered across topological sectors [−1.5, +1.5]</a:t>
+              <a:t>• Small / 2-D: CS f32 fastest (5.3× vs mumax3) — CUDA-Graph</a:t>
             </a:r>
           </a:p>
           <a:p>
             <a:pPr>
               <a:spcAft>
-                <a:spcPts val="700"/>
+                <a:spcPts val="800"/>
               </a:spcAft>
-              <a:defRPr sz="2200" b="0">
-                <a:solidFill>
-                  <a:srgbClr val="1F77B4"/>
-                </a:solidFill>
-              </a:defRPr>
-            </a:pPr>
-            <a:r>
-              <a:t>• mumax3 (relax &amp; minimize): deterministic, robust  →  the diagnostic signal</a:t>
-            </a:r>
-          </a:p>
-          <a:p>
-            <a:pPr lvl="1">
+              <a:defRPr sz="1600">
+                <a:solidFill>
+                  <a:srgbClr val="444444"/>
+                </a:solidFill>
+              </a:defRPr>
+            </a:pPr>
+            <a:r>
+              <a:t>• Large 3-D: mumax3 / MuMax-CO lead (cuFFT-bound)</a:t>
+            </a:r>
+          </a:p>
+          <a:p>
+            <a:pPr>
               <a:spcAft>
-                <a:spcPts val="700"/>
+                <a:spcPts val="800"/>
               </a:spcAft>
-              <a:defRPr sz="1900" b="0">
+              <a:defRPr sz="1600">
                 <a:solidFill>
                   <a:srgbClr val="444444"/>
                 </a:solidFill>
               </a:defRPr>
             </a:pPr>
             <a:r>
-              <a:t>   – A correct relaxation must not depend on thread scheduling  →  a defect</a:t>
-            </a:r>
-          </a:p>
-        </p:txBody>
-      </p:sp>
-      <p:sp>
-        <p:nvSpPr>
-          <p:cNvPr id="5" name="TextBox 4"/>
-          <p:cNvSpPr txBox="1"/>
-          <p:nvPr/>
-        </p:nvSpPr>
-        <p:spPr>
-          <a:xfrm>
-            <a:off x="640080" y="6263640"/>
-            <a:ext cx="10972800" cy="457200"/>
-          </a:xfrm>
-          <a:prstGeom prst="rect">
-            <a:avLst/>
-          </a:prstGeom>
-          <a:noFill/>
-        </p:spPr>
-        <p:txBody>
-          <a:bodyPr wrap="square">
-            <a:spAutoFit/>
-          </a:bodyPr>
-          <a:lstStyle/>
+              <a:t>• f32 = 4–6× f64 (Blackwell Tensor-Core)</a:t>
+            </a:r>
+          </a:p>
           <a:p>
             <a:pPr>
-              <a:defRPr sz="1200" i="1">
+              <a:spcAft>
+                <a:spcPts val="800"/>
+              </a:spcAft>
+              <a:defRPr sz="1600">
                 <a:solidFill>
                   <a:srgbClr val="444444"/>
                 </a:solidFill>
               </a:defRPr>
             </a:pPr>
             <a:r>
-              <a:t>Fig. 4a</a:t>
+              <a:t>• No single code wins everywhere</a:t>
             </a:r>
           </a:p>
         </p:txBody>
@@ -5289,14 +5703,14 @@
               </a:defRPr>
             </a:pPr>
             <a:r>
-              <a:t>Diagnosis → fix → determinism restored</a:t>
+              <a:t>Performance: cross-solver throughput</a:t>
             </a:r>
           </a:p>
         </p:txBody>
       </p:sp>
       <p:pic>
         <p:nvPicPr>
-          <p:cNvPr id="4" name="Picture 3" descr="Fig4_race_fix.png"/>
+          <p:cNvPr id="4" name="Picture 3" descr="Fig3a_throughput.png"/>
           <p:cNvPicPr>
             <a:picLocks noChangeAspect="1"/>
           </p:cNvPicPr>
@@ -5310,24 +5724,48 @@
         </p:blipFill>
         <p:spPr>
           <a:xfrm>
-            <a:off x="320040" y="1143000"/>
-            <a:ext cx="7315017" cy="2350503"/>
+            <a:off x="274320" y="1280160"/>
+            <a:ext cx="5547207" cy="3698138"/>
           </a:xfrm>
           <a:prstGeom prst="rect">
             <a:avLst/>
           </a:prstGeom>
         </p:spPr>
       </p:pic>
-      <p:sp>
-        <p:nvSpPr>
-          <p:cNvPr id="5" name="TextBox 4"/>
+      <p:pic>
+        <p:nvPicPr>
+          <p:cNvPr id="5" name="Picture 4" descr="Fig3b_scenario_bars.png"/>
+          <p:cNvPicPr>
+            <a:picLocks noChangeAspect="1"/>
+          </p:cNvPicPr>
+          <p:nvPr/>
+        </p:nvPicPr>
+        <p:blipFill>
+          <a:blip r:embed="rId3"/>
+          <a:stretch>
+            <a:fillRect/>
+          </a:stretch>
+        </p:blipFill>
+        <p:spPr>
+          <a:xfrm>
+            <a:off x="6370167" y="1280160"/>
+            <a:ext cx="5547207" cy="3081782"/>
+          </a:xfrm>
+          <a:prstGeom prst="rect">
+            <a:avLst/>
+          </a:prstGeom>
+        </p:spPr>
+      </p:pic>
+      <p:sp>
+        <p:nvSpPr>
+          <p:cNvPr id="6" name="TextBox 5"/>
           <p:cNvSpPr txBox="1"/>
           <p:nvPr/>
         </p:nvSpPr>
         <p:spPr>
           <a:xfrm>
-            <a:off x="7863657" y="1280160"/>
-            <a:ext cx="4053718" cy="4937760"/>
+            <a:off x="640080" y="6126480"/>
+            <a:ext cx="10972800" cy="548640"/>
           </a:xfrm>
           <a:prstGeom prst="rect">
             <a:avLst/>
@@ -5340,93 +5778,15 @@
           </a:bodyPr>
           <a:lstStyle/>
           <a:p>
-            <a:pPr>
-              <a:spcAft>
-                <a:spcPts val="800"/>
-              </a:spcAft>
-              <a:defRPr sz="1600">
+            <a:pPr algn="ctr">
+              <a:defRPr sz="1500">
                 <a:solidFill>
                   <a:srgbClr val="444444"/>
                 </a:solidFill>
               </a:defRPr>
             </a:pPr>
             <a:r>
-              <a:t>• Bisection: only damped-LLG + DMI scattered</a:t>
-            </a:r>
-          </a:p>
-          <a:p>
-            <a:pPr>
-              <a:spcAft>
-                <a:spcPts val="800"/>
-              </a:spcAft>
-              <a:defRPr sz="1600">
-                <a:solidFill>
-                  <a:srgbClr val="444444"/>
-                </a:solidFill>
-              </a:defRPr>
-            </a:pPr>
-            <a:r>
-              <a:t>• Cause: DMI GPU field missing set_stream override</a:t>
-            </a:r>
-          </a:p>
-          <a:p>
-            <a:pPr>
-              <a:spcAft>
-                <a:spcPts val="800"/>
-              </a:spcAft>
-              <a:defRPr sz="1600">
-                <a:solidFill>
-                  <a:srgbClr val="444444"/>
-                </a:solidFill>
-              </a:defRPr>
-            </a:pPr>
-            <a:r>
-              <a:t>• -&gt; ran on its own stream, racing on d_H_out</a:t>
-            </a:r>
-          </a:p>
-          <a:p>
-            <a:pPr>
-              <a:spcAft>
-                <a:spcPts val="800"/>
-              </a:spcAft>
-              <a:defRPr sz="1600">
-                <a:solidFill>
-                  <a:srgbClr val="444444"/>
-                </a:solidFill>
-              </a:defRPr>
-            </a:pPr>
-            <a:r>
-              <a:t>• (FieldSumGPU single-stream mode skips sync)</a:t>
-            </a:r>
-          </a:p>
-          <a:p>
-            <a:pPr>
-              <a:spcAft>
-                <a:spcPts val="800"/>
-              </a:spcAft>
-              <a:defRPr sz="1600">
-                <a:solidFill>
-                  <a:srgbClr val="444444"/>
-                </a:solidFill>
-              </a:defRPr>
-            </a:pPr>
-            <a:r>
-              <a:t>• Fix: add override -&gt; std(Q) = 0, all builds</a:t>
-            </a:r>
-          </a:p>
-          <a:p>
-            <a:pPr>
-              <a:spcAft>
-                <a:spcPts val="800"/>
-              </a:spcAft>
-              <a:defRPr sz="1600">
-                <a:solidFill>
-                  <a:srgbClr val="444444"/>
-                </a:solidFill>
-              </a:defRPr>
-            </a:pPr>
-            <a:r>
-              <a:t>• Invisible to single build &amp; standard problems</a:t>
+              <a:t>Throughput vs cell count (crossover ~0.1–0.5 M) and per-scenario ms/eval bars.</a:t>
             </a:r>
           </a:p>
         </p:txBody>

</xml_diff>

<commit_message>
Paper: add figure captions + speaker notes to talk deck
- Every figure now has an italic centered caption (Fig 1-6, S3).
- All 13 slides carry talk-style speaker notes (set_notes via notes_slide).
- Added caption()/set_notes() helpers; image_slide gains cap=/notes=.

Co-Authored-By: Claude Opus 4.8 <noreply@anthropic.com>
</commit_message>
<xml_diff>
--- a/paper/Claude-SD_talk.pptx
+++ b/paper/Claude-SD_talk.pptx
@@ -6,18 +6,18 @@
   </p:sldMasterIdLst>
   <p:sldIdLst>
     <p:sldId id="256" r:id="rId7"/>
-    <p:sldId id="257" r:id="rId8"/>
-    <p:sldId id="258" r:id="rId9"/>
-    <p:sldId id="259" r:id="rId10"/>
-    <p:sldId id="260" r:id="rId11"/>
-    <p:sldId id="261" r:id="rId12"/>
-    <p:sldId id="262" r:id="rId13"/>
-    <p:sldId id="263" r:id="rId14"/>
-    <p:sldId id="264" r:id="rId15"/>
-    <p:sldId id="265" r:id="rId16"/>
-    <p:sldId id="266" r:id="rId17"/>
-    <p:sldId id="267" r:id="rId18"/>
-    <p:sldId id="268" r:id="rId19"/>
+    <p:sldId id="257" r:id="rId9"/>
+    <p:sldId id="258" r:id="rId10"/>
+    <p:sldId id="259" r:id="rId11"/>
+    <p:sldId id="260" r:id="rId12"/>
+    <p:sldId id="261" r:id="rId13"/>
+    <p:sldId id="262" r:id="rId14"/>
+    <p:sldId id="263" r:id="rId15"/>
+    <p:sldId id="264" r:id="rId16"/>
+    <p:sldId id="265" r:id="rId17"/>
+    <p:sldId id="266" r:id="rId18"/>
+    <p:sldId id="267" r:id="rId19"/>
+    <p:sldId id="268" r:id="rId20"/>
   </p:sldIdLst>
   <p:sldSz cx="12191695" cy="6858000" type="screen4x3"/>
   <p:notesSz cx="6858000" cy="9144000"/>
@@ -117,6 +117,1266 @@
     </a:lvl9pPr>
   </p:defaultTextStyle>
 </p:presentation>
+</file>
+
+<file path=ppt/notesMasters/notesMaster1.xml><?xml version="1.0" encoding="utf-8"?>
+<p:notesMaster xmlns:a="http://schemas.openxmlformats.org/drawingml/2006/main" xmlns:p="http://schemas.openxmlformats.org/presentationml/2006/main" xmlns:r="http://schemas.openxmlformats.org/officeDocument/2006/relationships">
+  <p:cSld>
+    <p:bg>
+      <p:bgRef idx="1001">
+        <a:schemeClr val="bg1"/>
+      </p:bgRef>
+    </p:bg>
+    <p:spTree>
+      <p:nvGrpSpPr>
+        <p:cNvPr id="1" name=""/>
+        <p:cNvGrpSpPr/>
+        <p:nvPr/>
+      </p:nvGrpSpPr>
+      <p:grpSpPr>
+        <a:xfrm>
+          <a:off x="0" y="0"/>
+          <a:ext cx="0" cy="0"/>
+          <a:chOff x="0" y="0"/>
+          <a:chExt cx="0" cy="0"/>
+        </a:xfrm>
+      </p:grpSpPr>
+      <p:sp>
+        <p:nvSpPr>
+          <p:cNvPr id="2" name="Header Placeholder 1"/>
+          <p:cNvSpPr>
+            <a:spLocks noGrp="1"/>
+          </p:cNvSpPr>
+          <p:nvPr>
+            <p:ph type="hdr" sz="quarter"/>
+          </p:nvPr>
+        </p:nvSpPr>
+        <p:spPr>
+          <a:xfrm>
+            <a:off x="0" y="0"/>
+            <a:ext cx="2971800" cy="457200"/>
+          </a:xfrm>
+          <a:prstGeom prst="rect">
+            <a:avLst/>
+          </a:prstGeom>
+        </p:spPr>
+        <p:txBody>
+          <a:bodyPr vert="horz" lIns="91440" tIns="45720" rIns="91440" bIns="45720" rtlCol="0"/>
+          <a:lstStyle>
+            <a:lvl1pPr algn="l">
+              <a:defRPr sz="1200"/>
+            </a:lvl1pPr>
+          </a:lstStyle>
+          <a:p>
+            <a:endParaRPr lang="en-US"/>
+          </a:p>
+        </p:txBody>
+      </p:sp>
+      <p:sp>
+        <p:nvSpPr>
+          <p:cNvPr id="3" name="Date Placeholder 2"/>
+          <p:cNvSpPr>
+            <a:spLocks noGrp="1"/>
+          </p:cNvSpPr>
+          <p:nvPr>
+            <p:ph type="dt" idx="1"/>
+          </p:nvPr>
+        </p:nvSpPr>
+        <p:spPr>
+          <a:xfrm>
+            <a:off x="3884613" y="0"/>
+            <a:ext cx="2971800" cy="457200"/>
+          </a:xfrm>
+          <a:prstGeom prst="rect">
+            <a:avLst/>
+          </a:prstGeom>
+        </p:spPr>
+        <p:txBody>
+          <a:bodyPr vert="horz" lIns="91440" tIns="45720" rIns="91440" bIns="45720" rtlCol="0"/>
+          <a:lstStyle>
+            <a:lvl1pPr algn="r">
+              <a:defRPr sz="1200"/>
+            </a:lvl1pPr>
+          </a:lstStyle>
+          <a:p>
+            <a:fld id="{0F89C1C7-3DCD-1040-A9CF-14679D8B5DDD}" type="datetimeFigureOut">
+              <a:rPr lang="en-US" smtClean="0"/>
+              <a:t>10/17/16</a:t>
+            </a:fld>
+            <a:endParaRPr lang="en-US"/>
+          </a:p>
+        </p:txBody>
+      </p:sp>
+      <p:sp>
+        <p:nvSpPr>
+          <p:cNvPr id="4" name="Slide Image Placeholder 3"/>
+          <p:cNvSpPr>
+            <a:spLocks noGrp="1" noRot="1" noChangeAspect="1"/>
+          </p:cNvSpPr>
+          <p:nvPr>
+            <p:ph type="sldImg" idx="2"/>
+          </p:nvPr>
+        </p:nvSpPr>
+        <p:spPr>
+          <a:xfrm>
+            <a:off x="1143000" y="685800"/>
+            <a:ext cx="4572000" cy="3429000"/>
+          </a:xfrm>
+          <a:prstGeom prst="rect">
+            <a:avLst/>
+          </a:prstGeom>
+          <a:noFill/>
+          <a:ln w="12700">
+            <a:solidFill>
+              <a:prstClr val="black"/>
+            </a:solidFill>
+          </a:ln>
+        </p:spPr>
+        <p:txBody>
+          <a:bodyPr vert="horz" lIns="91440" tIns="45720" rIns="91440" bIns="45720" rtlCol="0" anchor="ctr"/>
+          <a:lstStyle/>
+          <a:p>
+            <a:endParaRPr lang="en-US"/>
+          </a:p>
+        </p:txBody>
+      </p:sp>
+      <p:sp>
+        <p:nvSpPr>
+          <p:cNvPr id="5" name="Notes Placeholder 4"/>
+          <p:cNvSpPr>
+            <a:spLocks noGrp="1"/>
+          </p:cNvSpPr>
+          <p:nvPr>
+            <p:ph type="body" sz="quarter" idx="3"/>
+          </p:nvPr>
+        </p:nvSpPr>
+        <p:spPr>
+          <a:xfrm>
+            <a:off x="685800" y="4343400"/>
+            <a:ext cx="5486400" cy="4114800"/>
+          </a:xfrm>
+          <a:prstGeom prst="rect">
+            <a:avLst/>
+          </a:prstGeom>
+        </p:spPr>
+        <p:txBody>
+          <a:bodyPr vert="horz" lIns="91440" tIns="45720" rIns="91440" bIns="45720" rtlCol="0"/>
+          <a:lstStyle/>
+          <a:p>
+            <a:pPr lvl="0"/>
+            <a:r>
+              <a:rPr lang="en-US" smtClean="0"/>
+              <a:t>Click to edit Master text styles</a:t>
+            </a:r>
+          </a:p>
+          <a:p>
+            <a:pPr lvl="1"/>
+            <a:r>
+              <a:rPr lang="en-US" smtClean="0"/>
+              <a:t>Second level</a:t>
+            </a:r>
+          </a:p>
+          <a:p>
+            <a:pPr lvl="2"/>
+            <a:r>
+              <a:rPr lang="en-US" smtClean="0"/>
+              <a:t>Third level</a:t>
+            </a:r>
+          </a:p>
+          <a:p>
+            <a:pPr lvl="3"/>
+            <a:r>
+              <a:rPr lang="en-US" smtClean="0"/>
+              <a:t>Fourth level</a:t>
+            </a:r>
+          </a:p>
+          <a:p>
+            <a:pPr lvl="4"/>
+            <a:r>
+              <a:rPr lang="en-US" smtClean="0"/>
+              <a:t>Fifth level</a:t>
+            </a:r>
+            <a:endParaRPr lang="en-US"/>
+          </a:p>
+        </p:txBody>
+      </p:sp>
+      <p:sp>
+        <p:nvSpPr>
+          <p:cNvPr id="6" name="Footer Placeholder 5"/>
+          <p:cNvSpPr>
+            <a:spLocks noGrp="1"/>
+          </p:cNvSpPr>
+          <p:nvPr>
+            <p:ph type="ftr" sz="quarter" idx="4"/>
+          </p:nvPr>
+        </p:nvSpPr>
+        <p:spPr>
+          <a:xfrm>
+            <a:off x="0" y="8685213"/>
+            <a:ext cx="2971800" cy="457200"/>
+          </a:xfrm>
+          <a:prstGeom prst="rect">
+            <a:avLst/>
+          </a:prstGeom>
+        </p:spPr>
+        <p:txBody>
+          <a:bodyPr vert="horz" lIns="91440" tIns="45720" rIns="91440" bIns="45720" rtlCol="0" anchor="b"/>
+          <a:lstStyle>
+            <a:lvl1pPr algn="l">
+              <a:defRPr sz="1200"/>
+            </a:lvl1pPr>
+          </a:lstStyle>
+          <a:p>
+            <a:endParaRPr lang="en-US"/>
+          </a:p>
+        </p:txBody>
+      </p:sp>
+      <p:sp>
+        <p:nvSpPr>
+          <p:cNvPr id="7" name="Slide Number Placeholder 6"/>
+          <p:cNvSpPr>
+            <a:spLocks noGrp="1"/>
+          </p:cNvSpPr>
+          <p:nvPr>
+            <p:ph type="sldNum" sz="quarter" idx="5"/>
+          </p:nvPr>
+        </p:nvSpPr>
+        <p:spPr>
+          <a:xfrm>
+            <a:off x="3884613" y="8685213"/>
+            <a:ext cx="2971800" cy="457200"/>
+          </a:xfrm>
+          <a:prstGeom prst="rect">
+            <a:avLst/>
+          </a:prstGeom>
+        </p:spPr>
+        <p:txBody>
+          <a:bodyPr vert="horz" lIns="91440" tIns="45720" rIns="91440" bIns="45720" rtlCol="0" anchor="b"/>
+          <a:lstStyle>
+            <a:lvl1pPr algn="r">
+              <a:defRPr sz="1200"/>
+            </a:lvl1pPr>
+          </a:lstStyle>
+          <a:p>
+            <a:fld id="{BB5E49A5-4136-284D-997B-48E1D791AD67}" type="slidenum">
+              <a:rPr lang="en-US" smtClean="0"/>
+              <a:t>‹#›</a:t>
+            </a:fld>
+            <a:endParaRPr lang="en-US"/>
+          </a:p>
+        </p:txBody>
+      </p:sp>
+    </p:spTree>
+    <p:extLst>
+      <p:ext uri="{BB962C8B-B14F-4D97-AF65-F5344CB8AC3E}">
+        <p14:creationId xmlns:p14="http://schemas.microsoft.com/office/powerpoint/2010/main" val="2623252185"/>
+      </p:ext>
+    </p:extLst>
+  </p:cSld>
+  <p:clrMap bg1="lt1" tx1="dk1" bg2="lt2" tx2="dk2" accent1="accent1" accent2="accent2" accent3="accent3" accent4="accent4" accent5="accent5" accent6="accent6" hlink="hlink" folHlink="folHlink"/>
+  <p:notesStyle>
+    <a:lvl1pPr marL="0" algn="l" defTabSz="457200" rtl="0" eaLnBrk="1" latinLnBrk="0" hangingPunct="1">
+      <a:defRPr sz="1200" kern="1200">
+        <a:solidFill>
+          <a:schemeClr val="tx1"/>
+        </a:solidFill>
+        <a:latin typeface="+mn-lt"/>
+        <a:ea typeface="+mn-ea"/>
+        <a:cs typeface="+mn-cs"/>
+      </a:defRPr>
+    </a:lvl1pPr>
+    <a:lvl2pPr marL="457200" algn="l" defTabSz="457200" rtl="0" eaLnBrk="1" latinLnBrk="0" hangingPunct="1">
+      <a:defRPr sz="1200" kern="1200">
+        <a:solidFill>
+          <a:schemeClr val="tx1"/>
+        </a:solidFill>
+        <a:latin typeface="+mn-lt"/>
+        <a:ea typeface="+mn-ea"/>
+        <a:cs typeface="+mn-cs"/>
+      </a:defRPr>
+    </a:lvl2pPr>
+    <a:lvl3pPr marL="914400" algn="l" defTabSz="457200" rtl="0" eaLnBrk="1" latinLnBrk="0" hangingPunct="1">
+      <a:defRPr sz="1200" kern="1200">
+        <a:solidFill>
+          <a:schemeClr val="tx1"/>
+        </a:solidFill>
+        <a:latin typeface="+mn-lt"/>
+        <a:ea typeface="+mn-ea"/>
+        <a:cs typeface="+mn-cs"/>
+      </a:defRPr>
+    </a:lvl3pPr>
+    <a:lvl4pPr marL="1371600" algn="l" defTabSz="457200" rtl="0" eaLnBrk="1" latinLnBrk="0" hangingPunct="1">
+      <a:defRPr sz="1200" kern="1200">
+        <a:solidFill>
+          <a:schemeClr val="tx1"/>
+        </a:solidFill>
+        <a:latin typeface="+mn-lt"/>
+        <a:ea typeface="+mn-ea"/>
+        <a:cs typeface="+mn-cs"/>
+      </a:defRPr>
+    </a:lvl4pPr>
+    <a:lvl5pPr marL="1828800" algn="l" defTabSz="457200" rtl="0" eaLnBrk="1" latinLnBrk="0" hangingPunct="1">
+      <a:defRPr sz="1200" kern="1200">
+        <a:solidFill>
+          <a:schemeClr val="tx1"/>
+        </a:solidFill>
+        <a:latin typeface="+mn-lt"/>
+        <a:ea typeface="+mn-ea"/>
+        <a:cs typeface="+mn-cs"/>
+      </a:defRPr>
+    </a:lvl5pPr>
+    <a:lvl6pPr marL="2286000" algn="l" defTabSz="457200" rtl="0" eaLnBrk="1" latinLnBrk="0" hangingPunct="1">
+      <a:defRPr sz="1200" kern="1200">
+        <a:solidFill>
+          <a:schemeClr val="tx1"/>
+        </a:solidFill>
+        <a:latin typeface="+mn-lt"/>
+        <a:ea typeface="+mn-ea"/>
+        <a:cs typeface="+mn-cs"/>
+      </a:defRPr>
+    </a:lvl6pPr>
+    <a:lvl7pPr marL="2743200" algn="l" defTabSz="457200" rtl="0" eaLnBrk="1" latinLnBrk="0" hangingPunct="1">
+      <a:defRPr sz="1200" kern="1200">
+        <a:solidFill>
+          <a:schemeClr val="tx1"/>
+        </a:solidFill>
+        <a:latin typeface="+mn-lt"/>
+        <a:ea typeface="+mn-ea"/>
+        <a:cs typeface="+mn-cs"/>
+      </a:defRPr>
+    </a:lvl7pPr>
+    <a:lvl8pPr marL="3200400" algn="l" defTabSz="457200" rtl="0" eaLnBrk="1" latinLnBrk="0" hangingPunct="1">
+      <a:defRPr sz="1200" kern="1200">
+        <a:solidFill>
+          <a:schemeClr val="tx1"/>
+        </a:solidFill>
+        <a:latin typeface="+mn-lt"/>
+        <a:ea typeface="+mn-ea"/>
+        <a:cs typeface="+mn-cs"/>
+      </a:defRPr>
+    </a:lvl8pPr>
+    <a:lvl9pPr marL="3657600" algn="l" defTabSz="457200" rtl="0" eaLnBrk="1" latinLnBrk="0" hangingPunct="1">
+      <a:defRPr sz="1200" kern="1200">
+        <a:solidFill>
+          <a:schemeClr val="tx1"/>
+        </a:solidFill>
+        <a:latin typeface="+mn-lt"/>
+        <a:ea typeface="+mn-ea"/>
+        <a:cs typeface="+mn-cs"/>
+      </a:defRPr>
+    </a:lvl9pPr>
+  </p:notesStyle>
+</p:notesMaster>
+</file>
+
+<file path=ppt/notesSlides/notesSlide1.xml><?xml version="1.0" encoding="utf-8"?>
+<p:notes xmlns:a="http://schemas.openxmlformats.org/drawingml/2006/main" xmlns:p="http://schemas.openxmlformats.org/presentationml/2006/main" xmlns:r="http://schemas.openxmlformats.org/officeDocument/2006/relationships">
+  <p:cSld>
+    <p:spTree>
+      <p:nvGrpSpPr>
+        <p:cNvPr id="1" name=""/>
+        <p:cNvGrpSpPr/>
+        <p:nvPr/>
+      </p:nvGrpSpPr>
+      <p:grpSpPr>
+        <a:xfrm>
+          <a:off x="0" y="0"/>
+          <a:ext cx="0" cy="0"/>
+          <a:chOff x="0" y="0"/>
+          <a:chExt cx="0" cy="0"/>
+        </a:xfrm>
+      </p:grpSpPr>
+      <p:sp>
+        <p:nvSpPr>
+          <p:cNvPr id="2" name="Slide Image Placeholder 1"/>
+          <p:cNvSpPr>
+            <a:spLocks noGrp="1"/>
+          </p:cNvSpPr>
+          <p:nvPr>
+            <p:ph type="sldImg" idx="2"/>
+          </p:nvPr>
+        </p:nvSpPr>
+        <p:spPr/>
+      </p:sp>
+      <p:sp>
+        <p:nvSpPr>
+          <p:cNvPr id="3" name="Notes Placeholder 2"/>
+          <p:cNvSpPr>
+            <a:spLocks noGrp="1"/>
+          </p:cNvSpPr>
+          <p:nvPr>
+            <p:ph type="body" idx="3" sz="quarter"/>
+          </p:nvPr>
+        </p:nvSpPr>
+        <p:spPr/>
+        <p:txBody>
+          <a:bodyPr/>
+          <a:lstStyle/>
+          <a:p>
+            <a:r>
+              <a:t>Opening. This talk is a case study: we used an AI coding agent to build a complete GPU micromagnetic simulator from scratch, validated it against the community standards, and — the punchline — the validation infrastructure itself caught a real GPU concurrency bug. So it is as much about a verification methodology as about the code. Target venue: npj Computational Materials.</a:t>
+            </a:r>
+          </a:p>
+        </p:txBody>
+      </p:sp>
+      <p:sp>
+        <p:nvSpPr>
+          <p:cNvPr id="4" name="Slide Number Placeholder 3"/>
+          <p:cNvSpPr>
+            <a:spLocks noGrp="1"/>
+          </p:cNvSpPr>
+          <p:nvPr>
+            <p:ph type="sldNum" idx="5" sz="quarter"/>
+          </p:nvPr>
+        </p:nvSpPr>
+        <p:spPr/>
+      </p:sp>
+    </p:spTree>
+  </p:cSld>
+  <p:clrMapOvr>
+    <a:masterClrMapping/>
+  </p:clrMapOvr>
+</p:notes>
+</file>
+
+<file path=ppt/notesSlides/notesSlide10.xml><?xml version="1.0" encoding="utf-8"?>
+<p:notes xmlns:a="http://schemas.openxmlformats.org/drawingml/2006/main" xmlns:p="http://schemas.openxmlformats.org/presentationml/2006/main" xmlns:r="http://schemas.openxmlformats.org/officeDocument/2006/relationships">
+  <p:cSld>
+    <p:spTree>
+      <p:nvGrpSpPr>
+        <p:cNvPr id="1" name=""/>
+        <p:cNvGrpSpPr/>
+        <p:nvPr/>
+      </p:nvGrpSpPr>
+      <p:grpSpPr>
+        <a:xfrm>
+          <a:off x="0" y="0"/>
+          <a:ext cx="0" cy="0"/>
+          <a:chOff x="0" y="0"/>
+          <a:chExt cx="0" cy="0"/>
+        </a:xfrm>
+      </p:grpSpPr>
+      <p:sp>
+        <p:nvSpPr>
+          <p:cNvPr id="2" name="Slide Image Placeholder 1"/>
+          <p:cNvSpPr>
+            <a:spLocks noGrp="1"/>
+          </p:cNvSpPr>
+          <p:nvPr>
+            <p:ph type="sldImg" idx="2"/>
+          </p:nvPr>
+        </p:nvSpPr>
+        <p:spPr/>
+      </p:sp>
+      <p:sp>
+        <p:nvSpPr>
+          <p:cNvPr id="3" name="Notes Placeholder 2"/>
+          <p:cNvSpPr>
+            <a:spLocks noGrp="1"/>
+          </p:cNvSpPr>
+          <p:nvPr>
+            <p:ph type="body" idx="3" sz="quarter"/>
+          </p:nvPr>
+        </p:nvSpPr>
+        <p:spPr/>
+        <p:txBody>
+          <a:bodyPr/>
+          <a:lstStyle/>
+          <a:p>
+            <a:r>
+              <a:t>Now the core result. We relax a seeded skyrmion across the DMI metastability boundary and record the topological charge Q. We found that the SAME build, run repeatedly with identical inputs, gave DIFFERENT Q — scatter up to 0.48 standard deviation, and crucially this happened even in double precision, so it is not a rounding-tolerance story. Meanwhile mumax3 was perfectly deterministic. A physically meaningful relaxation must not depend on thread scheduling, so this was a defect in our code — and the contrast with mumax3 is what flagged it.</a:t>
+            </a:r>
+          </a:p>
+        </p:txBody>
+      </p:sp>
+      <p:sp>
+        <p:nvSpPr>
+          <p:cNvPr id="4" name="Slide Number Placeholder 3"/>
+          <p:cNvSpPr>
+            <a:spLocks noGrp="1"/>
+          </p:cNvSpPr>
+          <p:nvPr>
+            <p:ph type="sldNum" idx="5" sz="quarter"/>
+          </p:nvPr>
+        </p:nvSpPr>
+        <p:spPr/>
+      </p:sp>
+    </p:spTree>
+  </p:cSld>
+  <p:clrMapOvr>
+    <a:masterClrMapping/>
+  </p:clrMapOvr>
+</p:notes>
+</file>
+
+<file path=ppt/notesSlides/notesSlide11.xml><?xml version="1.0" encoding="utf-8"?>
+<p:notes xmlns:a="http://schemas.openxmlformats.org/drawingml/2006/main" xmlns:p="http://schemas.openxmlformats.org/presentationml/2006/main" xmlns:r="http://schemas.openxmlformats.org/officeDocument/2006/relationships">
+  <p:cSld>
+    <p:spTree>
+      <p:nvGrpSpPr>
+        <p:cNvPr id="1" name=""/>
+        <p:cNvGrpSpPr/>
+        <p:nvPr/>
+      </p:nvGrpSpPr>
+      <p:grpSpPr>
+        <a:xfrm>
+          <a:off x="0" y="0"/>
+          <a:ext cx="0" cy="0"/>
+          <a:chOff x="0" y="0"/>
+          <a:chExt cx="0" cy="0"/>
+        </a:xfrm>
+      </p:grpSpPr>
+      <p:sp>
+        <p:nvSpPr>
+          <p:cNvPr id="2" name="Slide Image Placeholder 1"/>
+          <p:cNvSpPr>
+            <a:spLocks noGrp="1"/>
+          </p:cNvSpPr>
+          <p:nvPr>
+            <p:ph type="sldImg" idx="2"/>
+          </p:nvPr>
+        </p:nvSpPr>
+        <p:spPr/>
+      </p:sp>
+      <p:sp>
+        <p:nvSpPr>
+          <p:cNvPr id="3" name="Notes Placeholder 2"/>
+          <p:cNvSpPr>
+            <a:spLocks noGrp="1"/>
+          </p:cNvSpPr>
+          <p:nvPr>
+            <p:ph type="body" idx="3" sz="quarter"/>
+          </p:nvPr>
+        </p:nvSpPr>
+        <p:spPr/>
+        <p:txBody>
+          <a:bodyPr/>
+          <a:lstStyle/>
+          <a:p>
+            <a:r>
+              <a:t>Diagnosis by bisection: every field alone was deterministic, fixed-step RK4 was deterministic, but damped-LLG relaxation with DMI present scattered. The cause: the GPU DMI field carried its own CUDA stream but did not override the compositor's set_stream hook, so in single-stream mode — where the compositor skips inter-field synchronization — DMI ran concurrently and raced on the shared effective-field buffer. Near the bifurcation, last-bit differences flipped the topological sector. Adding the override collapses the Q standard deviation to zero across all builds, with all 113 GPU tests still green. The defect was invisible to any single build and to the standard problems.</a:t>
+            </a:r>
+          </a:p>
+        </p:txBody>
+      </p:sp>
+      <p:sp>
+        <p:nvSpPr>
+          <p:cNvPr id="4" name="Slide Number Placeholder 3"/>
+          <p:cNvSpPr>
+            <a:spLocks noGrp="1"/>
+          </p:cNvSpPr>
+          <p:nvPr>
+            <p:ph type="sldNum" idx="5" sz="quarter"/>
+          </p:nvPr>
+        </p:nvSpPr>
+        <p:spPr/>
+      </p:sp>
+    </p:spTree>
+  </p:cSld>
+  <p:clrMapOvr>
+    <a:masterClrMapping/>
+  </p:clrMapOvr>
+</p:notes>
+</file>
+
+<file path=ppt/notesSlides/notesSlide12.xml><?xml version="1.0" encoding="utf-8"?>
+<p:notes xmlns:a="http://schemas.openxmlformats.org/drawingml/2006/main" xmlns:p="http://schemas.openxmlformats.org/presentationml/2006/main" xmlns:r="http://schemas.openxmlformats.org/officeDocument/2006/relationships">
+  <p:cSld>
+    <p:spTree>
+      <p:nvGrpSpPr>
+        <p:cNvPr id="1" name=""/>
+        <p:cNvGrpSpPr/>
+        <p:nvPr/>
+      </p:nvGrpSpPr>
+      <p:grpSpPr>
+        <a:xfrm>
+          <a:off x="0" y="0"/>
+          <a:ext cx="0" cy="0"/>
+          <a:chOff x="0" y="0"/>
+          <a:chExt cx="0" cy="0"/>
+        </a:xfrm>
+      </p:grpSpPr>
+      <p:sp>
+        <p:nvSpPr>
+          <p:cNvPr id="2" name="Slide Image Placeholder 1"/>
+          <p:cNvSpPr>
+            <a:spLocks noGrp="1"/>
+          </p:cNvSpPr>
+          <p:nvPr>
+            <p:ph type="sldImg" idx="2"/>
+          </p:nvPr>
+        </p:nvSpPr>
+        <p:spPr/>
+      </p:sp>
+      <p:sp>
+        <p:nvSpPr>
+          <p:cNvPr id="3" name="Notes Placeholder 2"/>
+          <p:cNvSpPr>
+            <a:spLocks noGrp="1"/>
+          </p:cNvSpPr>
+          <p:nvPr>
+            <p:ph type="body" idx="3" sz="quarter"/>
+          </p:nvPr>
+        </p:nvSpPr>
+        <p:spPr/>
+        <p:txBody>
+          <a:bodyPr/>
+          <a:lstStyle/>
+          <a:p>
+            <a:r>
+              <a:t>The generalizable lesson. The agent did not write perfect code — it wrote a subtle concurrency bug that passed every unit test and every standard problem. What caught it was deliberately redundant design: multiple precisions, multiple FFT backends, and benchmarking against independent solvers. Discrepancy was the diagnostic. So the takeaway for AI-assisted scientific software is that cross-implementation validation should be a first-class design goal, precisely because the failure mode of agent code is plausible-looking code that is quietly wrong.</a:t>
+            </a:r>
+          </a:p>
+        </p:txBody>
+      </p:sp>
+      <p:sp>
+        <p:nvSpPr>
+          <p:cNvPr id="4" name="Slide Number Placeholder 3"/>
+          <p:cNvSpPr>
+            <a:spLocks noGrp="1"/>
+          </p:cNvSpPr>
+          <p:nvPr>
+            <p:ph type="sldNum" idx="5" sz="quarter"/>
+          </p:nvPr>
+        </p:nvSpPr>
+        <p:spPr/>
+      </p:sp>
+    </p:spTree>
+  </p:cSld>
+  <p:clrMapOvr>
+    <a:masterClrMapping/>
+  </p:clrMapOvr>
+</p:notes>
+</file>
+
+<file path=ppt/notesSlides/notesSlide13.xml><?xml version="1.0" encoding="utf-8"?>
+<p:notes xmlns:a="http://schemas.openxmlformats.org/drawingml/2006/main" xmlns:p="http://schemas.openxmlformats.org/presentationml/2006/main" xmlns:r="http://schemas.openxmlformats.org/officeDocument/2006/relationships">
+  <p:cSld>
+    <p:spTree>
+      <p:nvGrpSpPr>
+        <p:cNvPr id="1" name=""/>
+        <p:cNvGrpSpPr/>
+        <p:nvPr/>
+      </p:nvGrpSpPr>
+      <p:grpSpPr>
+        <a:xfrm>
+          <a:off x="0" y="0"/>
+          <a:ext cx="0" cy="0"/>
+          <a:chOff x="0" y="0"/>
+          <a:chExt cx="0" cy="0"/>
+        </a:xfrm>
+      </p:grpSpPr>
+      <p:sp>
+        <p:nvSpPr>
+          <p:cNvPr id="2" name="Slide Image Placeholder 1"/>
+          <p:cNvSpPr>
+            <a:spLocks noGrp="1"/>
+          </p:cNvSpPr>
+          <p:nvPr>
+            <p:ph type="sldImg" idx="2"/>
+          </p:nvPr>
+        </p:nvSpPr>
+        <p:spPr/>
+      </p:sp>
+      <p:sp>
+        <p:nvSpPr>
+          <p:cNvPr id="3" name="Notes Placeholder 2"/>
+          <p:cNvSpPr>
+            <a:spLocks noGrp="1"/>
+          </p:cNvSpPr>
+          <p:nvPr>
+            <p:ph type="body" idx="3" sz="quarter"/>
+          </p:nvPr>
+        </p:nvSpPr>
+        <p:spPr/>
+        <p:txBody>
+          <a:bodyPr/>
+          <a:lstStyle/>
+          <a:p>
+            <a:r>
+              <a:t>To summarize: an AI agent built a validated, dual-precision GPU micromagnetic simulator with competitive performance and a unique capability set. More importantly, its redundant design exposed and let us fix a real GPU concurrency defect. Everything is open under GPLv3 and fully reproducible — one command regenerates every table and figure — and it will be archived with a citable DOI on release. Thank you.</a:t>
+            </a:r>
+          </a:p>
+        </p:txBody>
+      </p:sp>
+      <p:sp>
+        <p:nvSpPr>
+          <p:cNvPr id="4" name="Slide Number Placeholder 3"/>
+          <p:cNvSpPr>
+            <a:spLocks noGrp="1"/>
+          </p:cNvSpPr>
+          <p:nvPr>
+            <p:ph type="sldNum" idx="5" sz="quarter"/>
+          </p:nvPr>
+        </p:nvSpPr>
+        <p:spPr/>
+      </p:sp>
+    </p:spTree>
+  </p:cSld>
+  <p:clrMapOvr>
+    <a:masterClrMapping/>
+  </p:clrMapOvr>
+</p:notes>
+</file>
+
+<file path=ppt/notesSlides/notesSlide2.xml><?xml version="1.0" encoding="utf-8"?>
+<p:notes xmlns:a="http://schemas.openxmlformats.org/drawingml/2006/main" xmlns:p="http://schemas.openxmlformats.org/presentationml/2006/main" xmlns:r="http://schemas.openxmlformats.org/officeDocument/2006/relationships">
+  <p:cSld>
+    <p:spTree>
+      <p:nvGrpSpPr>
+        <p:cNvPr id="1" name=""/>
+        <p:cNvGrpSpPr/>
+        <p:nvPr/>
+      </p:nvGrpSpPr>
+      <p:grpSpPr>
+        <a:xfrm>
+          <a:off x="0" y="0"/>
+          <a:ext cx="0" cy="0"/>
+          <a:chOff x="0" y="0"/>
+          <a:chExt cx="0" cy="0"/>
+        </a:xfrm>
+      </p:grpSpPr>
+      <p:sp>
+        <p:nvSpPr>
+          <p:cNvPr id="2" name="Slide Image Placeholder 1"/>
+          <p:cNvSpPr>
+            <a:spLocks noGrp="1"/>
+          </p:cNvSpPr>
+          <p:nvPr>
+            <p:ph type="sldImg" idx="2"/>
+          </p:nvPr>
+        </p:nvSpPr>
+        <p:spPr/>
+      </p:sp>
+      <p:sp>
+        <p:nvSpPr>
+          <p:cNvPr id="3" name="Notes Placeholder 2"/>
+          <p:cNvSpPr>
+            <a:spLocks noGrp="1"/>
+          </p:cNvSpPr>
+          <p:nvPr>
+            <p:ph type="body" idx="3" sz="quarter"/>
+          </p:nvPr>
+        </p:nvSpPr>
+        <p:spPr/>
+        <p:txBody>
+          <a:bodyPr/>
+          <a:lstStyle/>
+          <a:p>
+            <a:r>
+              <a:t>Motivation. Two open questions. First, can an agent produce something real — validated and fast — not a demo? Second, and more subtle: how do we trust it? Micromagnetics is an ideal testbed because the field has mature reference solvers and the NIST µMAG standard problems to anchor correctness. Note prior AI-for-science work mostly optimized existing codes; building and validating one from scratch is harder, and that's what we do here.</a:t>
+            </a:r>
+          </a:p>
+        </p:txBody>
+      </p:sp>
+      <p:sp>
+        <p:nvSpPr>
+          <p:cNvPr id="4" name="Slide Number Placeholder 3"/>
+          <p:cNvSpPr>
+            <a:spLocks noGrp="1"/>
+          </p:cNvSpPr>
+          <p:nvPr>
+            <p:ph type="sldNum" idx="5" sz="quarter"/>
+          </p:nvPr>
+        </p:nvSpPr>
+        <p:spPr/>
+      </p:sp>
+    </p:spTree>
+  </p:cSld>
+  <p:clrMapOvr>
+    <a:masterClrMapping/>
+  </p:clrMapOvr>
+</p:notes>
+</file>
+
+<file path=ppt/notesSlides/notesSlide3.xml><?xml version="1.0" encoding="utf-8"?>
+<p:notes xmlns:a="http://schemas.openxmlformats.org/drawingml/2006/main" xmlns:p="http://schemas.openxmlformats.org/presentationml/2006/main" xmlns:r="http://schemas.openxmlformats.org/officeDocument/2006/relationships">
+  <p:cSld>
+    <p:spTree>
+      <p:nvGrpSpPr>
+        <p:cNvPr id="1" name=""/>
+        <p:cNvGrpSpPr/>
+        <p:nvPr/>
+      </p:nvGrpSpPr>
+      <p:grpSpPr>
+        <a:xfrm>
+          <a:off x="0" y="0"/>
+          <a:ext cx="0" cy="0"/>
+          <a:chOff x="0" y="0"/>
+          <a:chExt cx="0" cy="0"/>
+        </a:xfrm>
+      </p:grpSpPr>
+      <p:sp>
+        <p:nvSpPr>
+          <p:cNvPr id="2" name="Slide Image Placeholder 1"/>
+          <p:cNvSpPr>
+            <a:spLocks noGrp="1"/>
+          </p:cNvSpPr>
+          <p:nvPr>
+            <p:ph type="sldImg" idx="2"/>
+          </p:nvPr>
+        </p:nvSpPr>
+        <p:spPr/>
+      </p:sp>
+      <p:sp>
+        <p:nvSpPr>
+          <p:cNvPr id="3" name="Notes Placeholder 2"/>
+          <p:cNvSpPr>
+            <a:spLocks noGrp="1"/>
+          </p:cNvSpPr>
+          <p:nvPr>
+            <p:ph type="body" idx="3" sz="quarter"/>
+          </p:nvPr>
+        </p:nvSpPr>
+        <p:spPr/>
+        <p:txBody>
+          <a:bodyPr/>
+          <a:lstStyle/>
+          <a:p>
+            <a:r>
+              <a:t>What we built. A full C++20/CUDA simulator with a Python API, solving the Landau-Lifshitz-Gilbert and stochastic-LLG equations. The headline differentiator versus the mumax family is double precision — they are float32-only — plus a second FFT backend (VkFFT) and a broad native physics set: spin-orbit and spin-transfer torques, DMI, RKKY, magnetoelastic, per-cell materials. Three integrators plus energy minimizers, with an auto-selection helper.</a:t>
+            </a:r>
+          </a:p>
+        </p:txBody>
+      </p:sp>
+      <p:sp>
+        <p:nvSpPr>
+          <p:cNvPr id="4" name="Slide Number Placeholder 3"/>
+          <p:cNvSpPr>
+            <a:spLocks noGrp="1"/>
+          </p:cNvSpPr>
+          <p:nvPr>
+            <p:ph type="sldNum" idx="5" sz="quarter"/>
+          </p:nvPr>
+        </p:nvSpPr>
+        <p:spPr/>
+      </p:sp>
+    </p:spTree>
+  </p:cSld>
+  <p:clrMapOvr>
+    <a:masterClrMapping/>
+  </p:clrMapOvr>
+</p:notes>
+</file>
+
+<file path=ppt/notesSlides/notesSlide4.xml><?xml version="1.0" encoding="utf-8"?>
+<p:notes xmlns:a="http://schemas.openxmlformats.org/drawingml/2006/main" xmlns:p="http://schemas.openxmlformats.org/presentationml/2006/main" xmlns:r="http://schemas.openxmlformats.org/officeDocument/2006/relationships">
+  <p:cSld>
+    <p:spTree>
+      <p:nvGrpSpPr>
+        <p:cNvPr id="1" name=""/>
+        <p:cNvGrpSpPr/>
+        <p:nvPr/>
+      </p:nvGrpSpPr>
+      <p:grpSpPr>
+        <a:xfrm>
+          <a:off x="0" y="0"/>
+          <a:ext cx="0" cy="0"/>
+          <a:chOff x="0" y="0"/>
+          <a:chExt cx="0" cy="0"/>
+        </a:xfrm>
+      </p:grpSpPr>
+      <p:sp>
+        <p:nvSpPr>
+          <p:cNvPr id="2" name="Slide Image Placeholder 1"/>
+          <p:cNvSpPr>
+            <a:spLocks noGrp="1"/>
+          </p:cNvSpPr>
+          <p:nvPr>
+            <p:ph type="sldImg" idx="2"/>
+          </p:nvPr>
+        </p:nvSpPr>
+        <p:spPr/>
+      </p:sp>
+      <p:sp>
+        <p:nvSpPr>
+          <p:cNvPr id="3" name="Notes Placeholder 2"/>
+          <p:cNvSpPr>
+            <a:spLocks noGrp="1"/>
+          </p:cNvSpPr>
+          <p:nvPr>
+            <p:ph type="body" idx="3" sz="quarter"/>
+          </p:nvPr>
+        </p:nvSpPr>
+        <p:spPr/>
+        <p:txBody>
+          <a:bodyPr/>
+          <a:lstStyle/>
+          <a:p>
+            <a:r>
+              <a:t>How it was built. A root specification file fixes the architecture layering, SI conventions, and the test map. The agent implements each feature as a CUDA kernel plus a CPU reference plus a Catch2 unit test, and a change is accepted only when all four CUDA build variants pass — f32/f64 times cuFFT/VkFFT. That redundant build matrix matters later. The loop closes with diagnose-and-fix; this is exactly how the DMI race we'll discuss was caught and repaired.</a:t>
+            </a:r>
+          </a:p>
+        </p:txBody>
+      </p:sp>
+      <p:sp>
+        <p:nvSpPr>
+          <p:cNvPr id="4" name="Slide Number Placeholder 3"/>
+          <p:cNvSpPr>
+            <a:spLocks noGrp="1"/>
+          </p:cNvSpPr>
+          <p:nvPr>
+            <p:ph type="sldNum" idx="5" sz="quarter"/>
+          </p:nvPr>
+        </p:nvSpPr>
+        <p:spPr/>
+      </p:sp>
+    </p:spTree>
+  </p:cSld>
+  <p:clrMapOvr>
+    <a:masterClrMapping/>
+  </p:clrMapOvr>
+</p:notes>
+</file>
+
+<file path=ppt/notesSlides/notesSlide5.xml><?xml version="1.0" encoding="utf-8"?>
+<p:notes xmlns:a="http://schemas.openxmlformats.org/drawingml/2006/main" xmlns:p="http://schemas.openxmlformats.org/presentationml/2006/main" xmlns:r="http://schemas.openxmlformats.org/officeDocument/2006/relationships">
+  <p:cSld>
+    <p:spTree>
+      <p:nvGrpSpPr>
+        <p:cNvPr id="1" name=""/>
+        <p:cNvGrpSpPr/>
+        <p:nvPr/>
+      </p:nvGrpSpPr>
+      <p:grpSpPr>
+        <a:xfrm>
+          <a:off x="0" y="0"/>
+          <a:ext cx="0" cy="0"/>
+          <a:chOff x="0" y="0"/>
+          <a:chExt cx="0" cy="0"/>
+        </a:xfrm>
+      </p:grpSpPr>
+      <p:sp>
+        <p:nvSpPr>
+          <p:cNvPr id="2" name="Slide Image Placeholder 1"/>
+          <p:cNvSpPr>
+            <a:spLocks noGrp="1"/>
+          </p:cNvSpPr>
+          <p:nvPr>
+            <p:ph type="sldImg" idx="2"/>
+          </p:nvPr>
+        </p:nvSpPr>
+        <p:spPr/>
+      </p:sp>
+      <p:sp>
+        <p:nvSpPr>
+          <p:cNvPr id="3" name="Notes Placeholder 2"/>
+          <p:cNvSpPr>
+            <a:spLocks noGrp="1"/>
+          </p:cNvSpPr>
+          <p:nvPr>
+            <p:ph type="body" idx="3" sz="quarter"/>
+          </p:nvPr>
+        </p:nvSpPr>
+        <p:spPr/>
+        <p:txBody>
+          <a:bodyPr/>
+          <a:lstStyle/>
+          <a:p>
+            <a:r>
+              <a:t>Scale of the effort, mined from git history. 155 commits over a month, ~137k lines of churn. The key point is the middle panel ratio: a test-to-source ratio of 0.55 and test cases growing in lockstep with features, from 7 to 345. This is test-driven development, not tests bolted on at the end — which is what made the cross-checking possible.</a:t>
+            </a:r>
+          </a:p>
+        </p:txBody>
+      </p:sp>
+      <p:sp>
+        <p:nvSpPr>
+          <p:cNvPr id="4" name="Slide Number Placeholder 3"/>
+          <p:cNvSpPr>
+            <a:spLocks noGrp="1"/>
+          </p:cNvSpPr>
+          <p:nvPr>
+            <p:ph type="sldNum" idx="5" sz="quarter"/>
+          </p:nvPr>
+        </p:nvSpPr>
+        <p:spPr/>
+      </p:sp>
+    </p:spTree>
+  </p:cSld>
+  <p:clrMapOvr>
+    <a:masterClrMapping/>
+  </p:clrMapOvr>
+</p:notes>
+</file>
+
+<file path=ppt/notesSlides/notesSlide6.xml><?xml version="1.0" encoding="utf-8"?>
+<p:notes xmlns:a="http://schemas.openxmlformats.org/drawingml/2006/main" xmlns:p="http://schemas.openxmlformats.org/presentationml/2006/main" xmlns:r="http://schemas.openxmlformats.org/officeDocument/2006/relationships">
+  <p:cSld>
+    <p:spTree>
+      <p:nvGrpSpPr>
+        <p:cNvPr id="1" name=""/>
+        <p:cNvGrpSpPr/>
+        <p:nvPr/>
+      </p:nvGrpSpPr>
+      <p:grpSpPr>
+        <a:xfrm>
+          <a:off x="0" y="0"/>
+          <a:ext cx="0" cy="0"/>
+          <a:chOff x="0" y="0"/>
+          <a:chExt cx="0" cy="0"/>
+        </a:xfrm>
+      </p:grpSpPr>
+      <p:sp>
+        <p:nvSpPr>
+          <p:cNvPr id="2" name="Slide Image Placeholder 1"/>
+          <p:cNvSpPr>
+            <a:spLocks noGrp="1"/>
+          </p:cNvSpPr>
+          <p:nvPr>
+            <p:ph type="sldImg" idx="2"/>
+          </p:nvPr>
+        </p:nvSpPr>
+        <p:spPr/>
+      </p:sp>
+      <p:sp>
+        <p:nvSpPr>
+          <p:cNvPr id="3" name="Notes Placeholder 2"/>
+          <p:cNvSpPr>
+            <a:spLocks noGrp="1"/>
+          </p:cNvSpPr>
+          <p:nvPr>
+            <p:ph type="body" idx="3" sz="quarter"/>
+          </p:nvPr>
+        </p:nvSpPr>
+        <p:spPr/>
+        <p:txBody>
+          <a:bodyPr/>
+          <a:lstStyle/>
+          <a:p>
+            <a:r>
+              <a:t>Correctness. We reproduce all five µMAG standard problems and agree with the independent solvers within their mutual spread. For the dynamic switching problem SP#4, our ⟨mx⟩ at 1 ns is −0.979; the OOMMF double-precision anchor is −0.984; the reference is −0.986 — all within 2%. SP#1 crossover length matches mumax+, and our newly added SP#2 matches mumax3 to better than 0.006.</a:t>
+            </a:r>
+          </a:p>
+        </p:txBody>
+      </p:sp>
+      <p:sp>
+        <p:nvSpPr>
+          <p:cNvPr id="4" name="Slide Number Placeholder 3"/>
+          <p:cNvSpPr>
+            <a:spLocks noGrp="1"/>
+          </p:cNvSpPr>
+          <p:nvPr>
+            <p:ph type="sldNum" idx="5" sz="quarter"/>
+          </p:nvPr>
+        </p:nvSpPr>
+        <p:spPr/>
+      </p:sp>
+    </p:spTree>
+  </p:cSld>
+  <p:clrMapOvr>
+    <a:masterClrMapping/>
+  </p:clrMapOvr>
+</p:notes>
+</file>
+
+<file path=ppt/notesSlides/notesSlide7.xml><?xml version="1.0" encoding="utf-8"?>
+<p:notes xmlns:a="http://schemas.openxmlformats.org/drawingml/2006/main" xmlns:p="http://schemas.openxmlformats.org/presentationml/2006/main" xmlns:r="http://schemas.openxmlformats.org/officeDocument/2006/relationships">
+  <p:cSld>
+    <p:spTree>
+      <p:nvGrpSpPr>
+        <p:cNvPr id="1" name=""/>
+        <p:cNvGrpSpPr/>
+        <p:nvPr/>
+      </p:nvGrpSpPr>
+      <p:grpSpPr>
+        <a:xfrm>
+          <a:off x="0" y="0"/>
+          <a:ext cx="0" cy="0"/>
+          <a:chOff x="0" y="0"/>
+          <a:chExt cx="0" cy="0"/>
+        </a:xfrm>
+      </p:grpSpPr>
+      <p:sp>
+        <p:nvSpPr>
+          <p:cNvPr id="2" name="Slide Image Placeholder 1"/>
+          <p:cNvSpPr>
+            <a:spLocks noGrp="1"/>
+          </p:cNvSpPr>
+          <p:nvPr>
+            <p:ph type="sldImg" idx="2"/>
+          </p:nvPr>
+        </p:nvSpPr>
+        <p:spPr/>
+      </p:sp>
+      <p:sp>
+        <p:nvSpPr>
+          <p:cNvPr id="3" name="Notes Placeholder 2"/>
+          <p:cNvSpPr>
+            <a:spLocks noGrp="1"/>
+          </p:cNvSpPr>
+          <p:nvPr>
+            <p:ph type="body" idx="3" sz="quarter"/>
+          </p:nvPr>
+        </p:nvSpPr>
+        <p:spPr/>
+        <p:txBody>
+          <a:bodyPr/>
+          <a:lstStyle/>
+          <a:p>
+            <a:r>
+              <a:t>A closer look at SP#2, which we implemented for this work: remanence and coercivity as a function of the reduced size d over the exchange length. Claude-SD (left) and the cross-solver overlay (right) track mumax3 to within 0.006 across the whole sweep, including the dip where flux closure sets in. This is a quantitative, not just qualitative, agreement.</a:t>
+            </a:r>
+          </a:p>
+        </p:txBody>
+      </p:sp>
+      <p:sp>
+        <p:nvSpPr>
+          <p:cNvPr id="4" name="Slide Number Placeholder 3"/>
+          <p:cNvSpPr>
+            <a:spLocks noGrp="1"/>
+          </p:cNvSpPr>
+          <p:nvPr>
+            <p:ph type="sldNum" idx="5" sz="quarter"/>
+          </p:nvPr>
+        </p:nvSpPr>
+        <p:spPr/>
+      </p:sp>
+    </p:spTree>
+  </p:cSld>
+  <p:clrMapOvr>
+    <a:masterClrMapping/>
+  </p:clrMapOvr>
+</p:notes>
+</file>
+
+<file path=ppt/notesSlides/notesSlide8.xml><?xml version="1.0" encoding="utf-8"?>
+<p:notes xmlns:a="http://schemas.openxmlformats.org/drawingml/2006/main" xmlns:p="http://schemas.openxmlformats.org/presentationml/2006/main" xmlns:r="http://schemas.openxmlformats.org/officeDocument/2006/relationships">
+  <p:cSld>
+    <p:spTree>
+      <p:nvGrpSpPr>
+        <p:cNvPr id="1" name=""/>
+        <p:cNvGrpSpPr/>
+        <p:nvPr/>
+      </p:nvGrpSpPr>
+      <p:grpSpPr>
+        <a:xfrm>
+          <a:off x="0" y="0"/>
+          <a:ext cx="0" cy="0"/>
+          <a:chOff x="0" y="0"/>
+          <a:chExt cx="0" cy="0"/>
+        </a:xfrm>
+      </p:grpSpPr>
+      <p:sp>
+        <p:nvSpPr>
+          <p:cNvPr id="2" name="Slide Image Placeholder 1"/>
+          <p:cNvSpPr>
+            <a:spLocks noGrp="1"/>
+          </p:cNvSpPr>
+          <p:nvPr>
+            <p:ph type="sldImg" idx="2"/>
+          </p:nvPr>
+        </p:nvSpPr>
+        <p:spPr/>
+      </p:sp>
+      <p:sp>
+        <p:nvSpPr>
+          <p:cNvPr id="3" name="Notes Placeholder 2"/>
+          <p:cNvSpPr>
+            <a:spLocks noGrp="1"/>
+          </p:cNvSpPr>
+          <p:nvPr>
+            <p:ph type="body" idx="3" sz="quarter"/>
+          </p:nvPr>
+        </p:nvSpPr>
+        <p:spPr/>
+        <p:txBody>
+          <a:bodyPr/>
+          <a:lstStyle/>
+          <a:p>
+            <a:r>
+              <a:t>Performance, the honest version. The capability matrix on the left shows where Claude-SD is broader (double precision, two backends). The landscape on the right shows a crossover near 0.1–0.5 million cells: below it our float32 build with CUDA-Graph replay is fastest — 5.3× over mumax3 on the SP#4 grid; above it the comparison becomes FFT-bound and the mumax family leads. Within Claude-SD, float32 is 4–6× faster than float64. The message: no single code wins everywhere.</a:t>
+            </a:r>
+          </a:p>
+        </p:txBody>
+      </p:sp>
+      <p:sp>
+        <p:nvSpPr>
+          <p:cNvPr id="4" name="Slide Number Placeholder 3"/>
+          <p:cNvSpPr>
+            <a:spLocks noGrp="1"/>
+          </p:cNvSpPr>
+          <p:nvPr>
+            <p:ph type="sldNum" idx="5" sz="quarter"/>
+          </p:nvPr>
+        </p:nvSpPr>
+        <p:spPr/>
+      </p:sp>
+    </p:spTree>
+  </p:cSld>
+  <p:clrMapOvr>
+    <a:masterClrMapping/>
+  </p:clrMapOvr>
+</p:notes>
+</file>
+
+<file path=ppt/notesSlides/notesSlide9.xml><?xml version="1.0" encoding="utf-8"?>
+<p:notes xmlns:a="http://schemas.openxmlformats.org/drawingml/2006/main" xmlns:p="http://schemas.openxmlformats.org/presentationml/2006/main" xmlns:r="http://schemas.openxmlformats.org/officeDocument/2006/relationships">
+  <p:cSld>
+    <p:spTree>
+      <p:nvGrpSpPr>
+        <p:cNvPr id="1" name=""/>
+        <p:cNvGrpSpPr/>
+        <p:nvPr/>
+      </p:nvGrpSpPr>
+      <p:grpSpPr>
+        <a:xfrm>
+          <a:off x="0" y="0"/>
+          <a:ext cx="0" cy="0"/>
+          <a:chOff x="0" y="0"/>
+          <a:chExt cx="0" cy="0"/>
+        </a:xfrm>
+      </p:grpSpPr>
+      <p:sp>
+        <p:nvSpPr>
+          <p:cNvPr id="2" name="Slide Image Placeholder 1"/>
+          <p:cNvSpPr>
+            <a:spLocks noGrp="1"/>
+          </p:cNvSpPr>
+          <p:nvPr>
+            <p:ph type="sldImg" idx="2"/>
+          </p:nvPr>
+        </p:nvSpPr>
+        <p:spPr/>
+      </p:sp>
+      <p:sp>
+        <p:nvSpPr>
+          <p:cNvPr id="3" name="Notes Placeholder 2"/>
+          <p:cNvSpPr>
+            <a:spLocks noGrp="1"/>
+          </p:cNvSpPr>
+          <p:nvPr>
+            <p:ph type="body" idx="3" sz="quarter"/>
+          </p:nvPr>
+        </p:nvSpPr>
+        <p:spPr/>
+        <p:txBody>
+          <a:bodyPr/>
+          <a:lstStyle/>
+          <a:p>
+            <a:r>
+              <a:t>The same story in throughput terms. Left: milliseconds per field-evaluation versus cell count for every solver — note we normalize by field-evaluations because the codes use different-order integrators, which is the only fair comparison. Right: the per-scenario bars. Small/2-D goes to Claude-SD float32; the largest 3-D grids go to MuMax-CO, with Claude-SD within about 1.1×.</a:t>
+            </a:r>
+          </a:p>
+        </p:txBody>
+      </p:sp>
+      <p:sp>
+        <p:nvSpPr>
+          <p:cNvPr id="4" name="Slide Number Placeholder 3"/>
+          <p:cNvSpPr>
+            <a:spLocks noGrp="1"/>
+          </p:cNvSpPr>
+          <p:nvPr>
+            <p:ph type="sldNum" idx="5" sz="quarter"/>
+          </p:nvPr>
+        </p:nvSpPr>
+        <p:spPr/>
+      </p:sp>
+    </p:spTree>
+  </p:cSld>
+  <p:clrMapOvr>
+    <a:masterClrMapping/>
+  </p:clrMapOvr>
+</p:notes>
 </file>
 
 <file path=ppt/slideLayouts/slideLayout1.xml><?xml version="1.0" encoding="utf-8"?>
@@ -3725,6 +4985,41 @@
           </a:p>
         </p:txBody>
       </p:sp>
+      <p:sp>
+        <p:nvSpPr>
+          <p:cNvPr id="6" name="TextBox 5"/>
+          <p:cNvSpPr txBox="1"/>
+          <p:nvPr/>
+        </p:nvSpPr>
+        <p:spPr>
+          <a:xfrm>
+            <a:off x="457200" y="6172200"/>
+            <a:ext cx="11247120" cy="548640"/>
+          </a:xfrm>
+          <a:prstGeom prst="rect">
+            <a:avLst/>
+          </a:prstGeom>
+          <a:noFill/>
+        </p:spPr>
+        <p:txBody>
+          <a:bodyPr wrap="square">
+            <a:spAutoFit/>
+          </a:bodyPr>
+          <a:lstStyle/>
+          <a:p>
+            <a:pPr algn="ctr">
+              <a:defRPr sz="1300" i="1">
+                <a:solidFill>
+                  <a:srgbClr val="444444"/>
+                </a:solidFill>
+              </a:defRPr>
+            </a:pPr>
+            <a:r>
+              <a:t>Fig 4 — Cross-validation exposes &amp; fixes a GPU stream race: Q before (scatter) → after (deterministic).</a:t>
+            </a:r>
+          </a:p>
+        </p:txBody>
+      </p:sp>
     </p:spTree>
   </p:cSld>
   <p:clrMapOvr>
@@ -4704,7 +5999,7 @@
         <p:spPr>
           <a:xfrm>
             <a:off x="320040" y="1143000"/>
-            <a:ext cx="7315017" cy="5212080"/>
+            <a:ext cx="7315017" cy="4937760"/>
           </a:xfrm>
           <a:prstGeom prst="rect">
             <a:avLst/>
@@ -4790,6 +6085,41 @@
             </a:pPr>
             <a:r>
               <a:t>• Fail -&gt; diagnose -&gt; fix (e.g. DMI race)</a:t>
+            </a:r>
+          </a:p>
+        </p:txBody>
+      </p:sp>
+      <p:sp>
+        <p:nvSpPr>
+          <p:cNvPr id="6" name="TextBox 5"/>
+          <p:cNvSpPr txBox="1"/>
+          <p:nvPr/>
+        </p:nvSpPr>
+        <p:spPr>
+          <a:xfrm>
+            <a:off x="457200" y="6172200"/>
+            <a:ext cx="11247120" cy="548640"/>
+          </a:xfrm>
+          <a:prstGeom prst="rect">
+            <a:avLst/>
+          </a:prstGeom>
+          <a:noFill/>
+        </p:spPr>
+        <p:txBody>
+          <a:bodyPr wrap="square">
+            <a:spAutoFit/>
+          </a:bodyPr>
+          <a:lstStyle/>
+          <a:p>
+            <a:pPr algn="ctr">
+              <a:defRPr sz="1300" i="1">
+                <a:solidFill>
+                  <a:srgbClr val="444444"/>
+                </a:solidFill>
+              </a:defRPr>
+            </a:pPr>
+            <a:r>
+              <a:t>Fig 1 — (a) AI-agent development &amp; verification loop; (b) Claude-SD architecture and capabilities.</a:t>
             </a:r>
           </a:p>
         </p:txBody>
@@ -5012,6 +6342,41 @@
           </a:p>
         </p:txBody>
       </p:sp>
+      <p:sp>
+        <p:nvSpPr>
+          <p:cNvPr id="6" name="TextBox 5"/>
+          <p:cNvSpPr txBox="1"/>
+          <p:nvPr/>
+        </p:nvSpPr>
+        <p:spPr>
+          <a:xfrm>
+            <a:off x="457200" y="6172200"/>
+            <a:ext cx="11247120" cy="548640"/>
+          </a:xfrm>
+          <a:prstGeom prst="rect">
+            <a:avLst/>
+          </a:prstGeom>
+          <a:noFill/>
+        </p:spPr>
+        <p:txBody>
+          <a:bodyPr wrap="square">
+            <a:spAutoFit/>
+          </a:bodyPr>
+          <a:lstStyle/>
+          <a:p>
+            <a:pPr algn="ctr">
+              <a:defRPr sz="1300" i="1">
+                <a:solidFill>
+                  <a:srgbClr val="444444"/>
+                </a:solidFill>
+              </a:defRPr>
+            </a:pPr>
+            <a:r>
+              <a:t>Fig 6 — Agent-driven metrics: test-case growth, code composition, commit cadence.</a:t>
+            </a:r>
+          </a:p>
+        </p:txBody>
+      </p:sp>
     </p:spTree>
   </p:cSld>
   <p:clrMapOvr>
@@ -5215,6 +6580,41 @@
           </a:p>
         </p:txBody>
       </p:sp>
+      <p:sp>
+        <p:nvSpPr>
+          <p:cNvPr id="6" name="TextBox 5"/>
+          <p:cNvSpPr txBox="1"/>
+          <p:nvPr/>
+        </p:nvSpPr>
+        <p:spPr>
+          <a:xfrm>
+            <a:off x="457200" y="6172200"/>
+            <a:ext cx="11247120" cy="548640"/>
+          </a:xfrm>
+          <a:prstGeom prst="rect">
+            <a:avLst/>
+          </a:prstGeom>
+          <a:noFill/>
+        </p:spPr>
+        <p:txBody>
+          <a:bodyPr wrap="square">
+            <a:spAutoFit/>
+          </a:bodyPr>
+          <a:lstStyle/>
+          <a:p>
+            <a:pPr algn="ctr">
+              <a:defRPr sz="1300" i="1">
+                <a:solidFill>
+                  <a:srgbClr val="444444"/>
+                </a:solidFill>
+              </a:defRPr>
+            </a:pPr>
+            <a:r>
+              <a:t>Fig 2 — µMAG standard problems SP#1–SP#5 reproduced (Claude-SD, double precision).</a:t>
+            </a:r>
+          </a:p>
+        </p:txBody>
+      </p:sp>
     </p:spTree>
   </p:cSld>
   <p:clrMapOvr>
@@ -5367,8 +6767,8 @@
         </p:nvSpPr>
         <p:spPr>
           <a:xfrm>
-            <a:off x="640080" y="6126480"/>
-            <a:ext cx="10972800" cy="548640"/>
+            <a:off x="457200" y="6035040"/>
+            <a:ext cx="11247120" cy="548640"/>
           </a:xfrm>
           <a:prstGeom prst="rect">
             <a:avLst/>
@@ -5382,14 +6782,14 @@
           <a:lstStyle/>
           <a:p>
             <a:pPr algn="ctr">
-              <a:defRPr sz="1500">
+              <a:defRPr sz="1300" i="1">
                 <a:solidFill>
                   <a:srgbClr val="444444"/>
                 </a:solidFill>
               </a:defRPr>
             </a:pPr>
             <a:r>
-              <a:t>Remanent ⟨m⟩/M_s and coercivity vs d/ℓ_ex; Claude-SD vs mumax3 (≤0.006).</a:t>
+              <a:t>Fig S3 — SP#2 remanent ⟨m⟩/M_s and coercivity vs d/ℓ_ex; Claude-SD vs mumax3.</a:t>
             </a:r>
           </a:p>
         </p:txBody>
@@ -5612,6 +7012,41 @@
           </a:p>
         </p:txBody>
       </p:sp>
+      <p:sp>
+        <p:nvSpPr>
+          <p:cNvPr id="6" name="TextBox 5"/>
+          <p:cNvSpPr txBox="1"/>
+          <p:nvPr/>
+        </p:nvSpPr>
+        <p:spPr>
+          <a:xfrm>
+            <a:off x="457200" y="6172200"/>
+            <a:ext cx="11247120" cy="548640"/>
+          </a:xfrm>
+          <a:prstGeom prst="rect">
+            <a:avLst/>
+          </a:prstGeom>
+          <a:noFill/>
+        </p:spPr>
+        <p:txBody>
+          <a:bodyPr wrap="square">
+            <a:spAutoFit/>
+          </a:bodyPr>
+          <a:lstStyle/>
+          <a:p>
+            <a:pPr algn="ctr">
+              <a:defRPr sz="1300" i="1">
+                <a:solidFill>
+                  <a:srgbClr val="444444"/>
+                </a:solidFill>
+              </a:defRPr>
+            </a:pPr>
+            <a:r>
+              <a:t>Fig 5 — Solver capability matrix (left) and throughput landscape (right).</a:t>
+            </a:r>
+          </a:p>
+        </p:txBody>
+      </p:sp>
     </p:spTree>
   </p:cSld>
   <p:clrMapOvr>
@@ -5764,8 +7199,8 @@
         </p:nvSpPr>
         <p:spPr>
           <a:xfrm>
-            <a:off x="640080" y="6126480"/>
-            <a:ext cx="10972800" cy="548640"/>
+            <a:off x="457200" y="6035040"/>
+            <a:ext cx="11247120" cy="548640"/>
           </a:xfrm>
           <a:prstGeom prst="rect">
             <a:avLst/>
@@ -5779,14 +7214,14 @@
           <a:lstStyle/>
           <a:p>
             <a:pPr algn="ctr">
-              <a:defRPr sz="1500">
+              <a:defRPr sz="1300" i="1">
                 <a:solidFill>
                   <a:srgbClr val="444444"/>
                 </a:solidFill>
               </a:defRPr>
             </a:pPr>
             <a:r>
-              <a:t>Throughput vs cell count (crossover ~0.1–0.5 M) and per-scenario ms/eval bars.</a:t>
+              <a:t>Fig 3 — Throughput vs cell count (crossover) and per-scenario ms per field-eval.</a:t>
             </a:r>
           </a:p>
         </p:txBody>
@@ -6117,4 +7552,324 @@
   </a:objectDefaults>
   <a:extraClrSchemeLst/>
 </a:theme>
+</file>
+
+<file path=ppt/theme/theme2.xml><?xml version="1.0" encoding="utf-8"?>
+<a:theme xmlns:a="http://schemas.openxmlformats.org/drawingml/2006/main" name="Office Theme">
+  <a:themeElements>
+    <a:clrScheme name="Office">
+      <a:dk1>
+        <a:sysClr val="windowText" lastClr="000000"/>
+      </a:dk1>
+      <a:lt1>
+        <a:sysClr val="window" lastClr="FFFFFF"/>
+      </a:lt1>
+      <a:dk2>
+        <a:srgbClr val="1F497D"/>
+      </a:dk2>
+      <a:lt2>
+        <a:srgbClr val="EEECE1"/>
+      </a:lt2>
+      <a:accent1>
+        <a:srgbClr val="4F81BD"/>
+      </a:accent1>
+      <a:accent2>
+        <a:srgbClr val="C0504D"/>
+      </a:accent2>
+      <a:accent3>
+        <a:srgbClr val="9BBB59"/>
+      </a:accent3>
+      <a:accent4>
+        <a:srgbClr val="8064A2"/>
+      </a:accent4>
+      <a:accent5>
+        <a:srgbClr val="4BACC6"/>
+      </a:accent5>
+      <a:accent6>
+        <a:srgbClr val="F79646"/>
+      </a:accent6>
+      <a:hlink>
+        <a:srgbClr val="0000FF"/>
+      </a:hlink>
+      <a:folHlink>
+        <a:srgbClr val="800080"/>
+      </a:folHlink>
+    </a:clrScheme>
+    <a:fontScheme name="Office">
+      <a:majorFont>
+        <a:latin typeface="Calibri"/>
+        <a:ea typeface=""/>
+        <a:cs typeface=""/>
+        <a:font script="Jpan" typeface="ＭＳ Ｐゴシック"/>
+        <a:font script="Hang" typeface="맑은 고딕"/>
+        <a:font script="Hans" typeface="宋体"/>
+        <a:font script="Hant" typeface="新細明體"/>
+        <a:font script="Arab" typeface="Times New Roman"/>
+        <a:font script="Hebr" typeface="Times New Roman"/>
+        <a:font script="Thai" typeface="Angsana New"/>
+        <a:font script="Ethi" typeface="Nyala"/>
+        <a:font script="Beng" typeface="Vrinda"/>
+        <a:font script="Gujr" typeface="Shruti"/>
+        <a:font script="Khmr" typeface="MoolBoran"/>
+        <a:font script="Knda" typeface="Tunga"/>
+        <a:font script="Guru" typeface="Raavi"/>
+        <a:font script="Cans" typeface="Euphemia"/>
+        <a:font script="Cher" typeface="Plantagenet Cherokee"/>
+        <a:font script="Yiii" typeface="Microsoft Yi Baiti"/>
+        <a:font script="Tibt" typeface="Microsoft Himalaya"/>
+        <a:font script="Thaa" typeface="MV Boli"/>
+        <a:font script="Deva" typeface="Mangal"/>
+        <a:font script="Telu" typeface="Gautami"/>
+        <a:font script="Taml" typeface="Latha"/>
+        <a:font script="Syrc" typeface="Estrangelo Edessa"/>
+        <a:font script="Orya" typeface="Kalinga"/>
+        <a:font script="Mlym" typeface="Kartika"/>
+        <a:font script="Laoo" typeface="DokChampa"/>
+        <a:font script="Sinh" typeface="Iskoola Pota"/>
+        <a:font script="Mong" typeface="Mongolian Baiti"/>
+        <a:font script="Viet" typeface="Times New Roman"/>
+        <a:font script="Uigh" typeface="Microsoft Uighur"/>
+        <a:font script="Geor" typeface="Sylfaen"/>
+      </a:majorFont>
+      <a:minorFont>
+        <a:latin typeface="Calibri"/>
+        <a:ea typeface=""/>
+        <a:cs typeface=""/>
+        <a:font script="Jpan" typeface="ＭＳ Ｐゴシック"/>
+        <a:font script="Hang" typeface="맑은 고딕"/>
+        <a:font script="Hans" typeface="宋体"/>
+        <a:font script="Hant" typeface="新細明體"/>
+        <a:font script="Arab" typeface="Arial"/>
+        <a:font script="Hebr" typeface="Arial"/>
+        <a:font script="Thai" typeface="Cordia New"/>
+        <a:font script="Ethi" typeface="Nyala"/>
+        <a:font script="Beng" typeface="Vrinda"/>
+        <a:font script="Gujr" typeface="Shruti"/>
+        <a:font script="Khmr" typeface="DaunPenh"/>
+        <a:font script="Knda" typeface="Tunga"/>
+        <a:font script="Guru" typeface="Raavi"/>
+        <a:font script="Cans" typeface="Euphemia"/>
+        <a:font script="Cher" typeface="Plantagenet Cherokee"/>
+        <a:font script="Yiii" typeface="Microsoft Yi Baiti"/>
+        <a:font script="Tibt" typeface="Microsoft Himalaya"/>
+        <a:font script="Thaa" typeface="MV Boli"/>
+        <a:font script="Deva" typeface="Mangal"/>
+        <a:font script="Telu" typeface="Gautami"/>
+        <a:font script="Taml" typeface="Latha"/>
+        <a:font script="Syrc" typeface="Estrangelo Edessa"/>
+        <a:font script="Orya" typeface="Kalinga"/>
+        <a:font script="Mlym" typeface="Kartika"/>
+        <a:font script="Laoo" typeface="DokChampa"/>
+        <a:font script="Sinh" typeface="Iskoola Pota"/>
+        <a:font script="Mong" typeface="Mongolian Baiti"/>
+        <a:font script="Viet" typeface="Arial"/>
+        <a:font script="Uigh" typeface="Microsoft Uighur"/>
+        <a:font script="Geor" typeface="Sylfaen"/>
+      </a:minorFont>
+    </a:fontScheme>
+    <a:fmtScheme name="Office">
+      <a:fillStyleLst>
+        <a:solidFill>
+          <a:schemeClr val="phClr"/>
+        </a:solidFill>
+        <a:gradFill rotWithShape="1">
+          <a:gsLst>
+            <a:gs pos="0">
+              <a:schemeClr val="phClr">
+                <a:tint val="50000"/>
+                <a:satMod val="300000"/>
+              </a:schemeClr>
+            </a:gs>
+            <a:gs pos="35000">
+              <a:schemeClr val="phClr">
+                <a:tint val="37000"/>
+                <a:satMod val="300000"/>
+              </a:schemeClr>
+            </a:gs>
+            <a:gs pos="100000">
+              <a:schemeClr val="phClr">
+                <a:tint val="15000"/>
+                <a:satMod val="350000"/>
+              </a:schemeClr>
+            </a:gs>
+          </a:gsLst>
+          <a:lin ang="16200000" scaled="1"/>
+        </a:gradFill>
+        <a:gradFill rotWithShape="1">
+          <a:gsLst>
+            <a:gs pos="0">
+              <a:schemeClr val="phClr">
+                <a:tint val="100000"/>
+                <a:shade val="100000"/>
+                <a:satMod val="130000"/>
+              </a:schemeClr>
+            </a:gs>
+            <a:gs pos="100000">
+              <a:schemeClr val="phClr">
+                <a:tint val="50000"/>
+                <a:shade val="100000"/>
+                <a:satMod val="350000"/>
+              </a:schemeClr>
+            </a:gs>
+          </a:gsLst>
+          <a:lin ang="16200000" scaled="0"/>
+        </a:gradFill>
+      </a:fillStyleLst>
+      <a:lnStyleLst>
+        <a:ln w="9525" cap="flat" cmpd="sng" algn="ctr">
+          <a:solidFill>
+            <a:schemeClr val="phClr">
+              <a:shade val="95000"/>
+              <a:satMod val="105000"/>
+            </a:schemeClr>
+          </a:solidFill>
+          <a:prstDash val="solid"/>
+        </a:ln>
+        <a:ln w="25400" cap="flat" cmpd="sng" algn="ctr">
+          <a:solidFill>
+            <a:schemeClr val="phClr"/>
+          </a:solidFill>
+          <a:prstDash val="solid"/>
+        </a:ln>
+        <a:ln w="38100" cap="flat" cmpd="sng" algn="ctr">
+          <a:solidFill>
+            <a:schemeClr val="phClr"/>
+          </a:solidFill>
+          <a:prstDash val="solid"/>
+        </a:ln>
+      </a:lnStyleLst>
+      <a:effectStyleLst>
+        <a:effectStyle>
+          <a:effectLst>
+            <a:outerShdw blurRad="40000" dist="20000" dir="5400000" rotWithShape="0">
+              <a:srgbClr val="000000">
+                <a:alpha val="38000"/>
+              </a:srgbClr>
+            </a:outerShdw>
+          </a:effectLst>
+        </a:effectStyle>
+        <a:effectStyle>
+          <a:effectLst>
+            <a:outerShdw blurRad="40000" dist="23000" dir="5400000" rotWithShape="0">
+              <a:srgbClr val="000000">
+                <a:alpha val="35000"/>
+              </a:srgbClr>
+            </a:outerShdw>
+          </a:effectLst>
+        </a:effectStyle>
+        <a:effectStyle>
+          <a:effectLst>
+            <a:outerShdw blurRad="40000" dist="23000" dir="5400000" rotWithShape="0">
+              <a:srgbClr val="000000">
+                <a:alpha val="35000"/>
+              </a:srgbClr>
+            </a:outerShdw>
+          </a:effectLst>
+          <a:scene3d>
+            <a:camera prst="orthographicFront">
+              <a:rot lat="0" lon="0" rev="0"/>
+            </a:camera>
+            <a:lightRig rig="threePt" dir="t">
+              <a:rot lat="0" lon="0" rev="1200000"/>
+            </a:lightRig>
+          </a:scene3d>
+          <a:sp3d>
+            <a:bevelT w="63500" h="25400"/>
+          </a:sp3d>
+        </a:effectStyle>
+      </a:effectStyleLst>
+      <a:bgFillStyleLst>
+        <a:solidFill>
+          <a:schemeClr val="phClr"/>
+        </a:solidFill>
+        <a:gradFill rotWithShape="1">
+          <a:gsLst>
+            <a:gs pos="0">
+              <a:schemeClr val="phClr">
+                <a:tint val="40000"/>
+                <a:satMod val="350000"/>
+              </a:schemeClr>
+            </a:gs>
+            <a:gs pos="40000">
+              <a:schemeClr val="phClr">
+                <a:tint val="45000"/>
+                <a:shade val="99000"/>
+                <a:satMod val="350000"/>
+              </a:schemeClr>
+            </a:gs>
+            <a:gs pos="100000">
+              <a:schemeClr val="phClr">
+                <a:shade val="20000"/>
+                <a:satMod val="255000"/>
+              </a:schemeClr>
+            </a:gs>
+          </a:gsLst>
+          <a:path path="circle">
+            <a:fillToRect l="50000" t="-80000" r="50000" b="180000"/>
+          </a:path>
+        </a:gradFill>
+        <a:gradFill rotWithShape="1">
+          <a:gsLst>
+            <a:gs pos="0">
+              <a:schemeClr val="phClr">
+                <a:tint val="80000"/>
+                <a:satMod val="300000"/>
+              </a:schemeClr>
+            </a:gs>
+            <a:gs pos="100000">
+              <a:schemeClr val="phClr">
+                <a:shade val="30000"/>
+                <a:satMod val="200000"/>
+              </a:schemeClr>
+            </a:gs>
+          </a:gsLst>
+          <a:path path="circle">
+            <a:fillToRect l="50000" t="50000" r="50000" b="50000"/>
+          </a:path>
+        </a:gradFill>
+      </a:bgFillStyleLst>
+    </a:fmtScheme>
+  </a:themeElements>
+  <a:objectDefaults>
+    <a:spDef>
+      <a:spPr/>
+      <a:bodyPr/>
+      <a:lstStyle/>
+      <a:style>
+        <a:lnRef idx="1">
+          <a:schemeClr val="accent1"/>
+        </a:lnRef>
+        <a:fillRef idx="3">
+          <a:schemeClr val="accent1"/>
+        </a:fillRef>
+        <a:effectRef idx="2">
+          <a:schemeClr val="accent1"/>
+        </a:effectRef>
+        <a:fontRef idx="minor">
+          <a:schemeClr val="lt1"/>
+        </a:fontRef>
+      </a:style>
+    </a:spDef>
+    <a:lnDef>
+      <a:spPr/>
+      <a:bodyPr/>
+      <a:lstStyle/>
+      <a:style>
+        <a:lnRef idx="2">
+          <a:schemeClr val="accent1"/>
+        </a:lnRef>
+        <a:fillRef idx="0">
+          <a:schemeClr val="accent1"/>
+        </a:fillRef>
+        <a:effectRef idx="1">
+          <a:schemeClr val="accent1"/>
+        </a:effectRef>
+        <a:fontRef idx="minor">
+          <a:schemeClr val="tx1"/>
+        </a:fontRef>
+      </a:style>
+    </a:lnDef>
+  </a:objectDefaults>
+  <a:extraClrSchemeLst/>
+</a:theme>
 </file>
</xml_diff>